<commit_message>
report: preserve user edits to October 23 FlashReFocus slides
</commit_message>
<xml_diff>
--- a/汇报/2026-10-23_ATB进展与FlashReFocus/FlashReFocus_论文介绍_1023.pptx
+++ b/汇报/2026-10-23_ATB进展与FlashReFocus/FlashReFocus_论文介绍_1023.pptx
@@ -5,11 +5,11 @@
     <p:sldMasterId id="2147483648" r:id="rId1"/>
   </p:sldMasterIdLst>
   <p:notesMasterIdLst>
-    <p:notesMasterId r:id="rId16"/>
+    <p:notesMasterId r:id="rId4"/>
   </p:notesMasterIdLst>
   <p:sldIdLst>
-    <p:sldId id="257" r:id="rId8"/>
-    <p:sldId id="258" r:id="rId9"/>
+    <p:sldId id="257" r:id="rId2"/>
+    <p:sldId id="258" r:id="rId3"/>
   </p:sldIdLst>
   <p:sldSz cx="12192000" cy="6858000"/>
   <p:notesSz cx="6858000" cy="9144000"/>
@@ -287,8 +287,8 @@
 </p:notesMaster>
 </file>
 
-<file path=ppt/notesSlides/notesSlide2.xml><?xml version="1.0" encoding="utf-8"?>
-<p:notes xmlns:a="http://schemas.openxmlformats.org/drawingml/2006/main" xmlns:p="http://schemas.openxmlformats.org/presentationml/2006/main" xmlns:r="http://schemas.openxmlformats.org/officeDocument/2006/relationships">
+<file path=ppt/notesSlides/notesSlide1.xml><?xml version="1.0" encoding="utf-8"?>
+<p:notes xmlns:a="http://schemas.openxmlformats.org/drawingml/2006/main" xmlns:r="http://schemas.openxmlformats.org/officeDocument/2006/relationships" xmlns:p="http://schemas.openxmlformats.org/presentationml/2006/main">
   <p:cSld>
     <p:spTree>
       <p:nvGrpSpPr>
@@ -308,7 +308,7 @@
         <p:nvSpPr>
           <p:cNvPr id="2" name="Slide Image Placeholder 1"/>
           <p:cNvSpPr>
-            <a:spLocks noGrp="1"/>
+            <a:spLocks noGrp="1" noRot="1" noChangeAspect="1"/>
           </p:cNvSpPr>
           <p:nvPr>
             <p:ph type="sldImg" idx="2"/>
@@ -323,14 +323,16 @@
             <a:spLocks noGrp="1"/>
           </p:cNvSpPr>
           <p:nvPr>
-            <p:ph type="body" idx="3" sz="quarter"/>
+            <p:ph type="body" sz="quarter" idx="3"/>
           </p:nvPr>
         </p:nvSpPr>
         <p:spPr/>
         <p:txBody>
           <a:bodyPr/>
           <a:lstStyle/>
-          <a:p/>
+          <a:p>
+            <a:endParaRPr/>
+          </a:p>
         </p:txBody>
       </p:sp>
       <p:sp>
@@ -340,7 +342,7 @@
             <a:spLocks noGrp="1"/>
           </p:cNvSpPr>
           <p:nvPr>
-            <p:ph type="sldNum" idx="5" sz="quarter"/>
+            <p:ph type="sldNum" sz="quarter" idx="5"/>
           </p:nvPr>
         </p:nvSpPr>
         <p:spPr/>
@@ -353,8 +355,8 @@
 </p:notes>
 </file>
 
-<file path=ppt/notesSlides/notesSlide3.xml><?xml version="1.0" encoding="utf-8"?>
-<p:notes xmlns:a="http://schemas.openxmlformats.org/drawingml/2006/main" xmlns:p="http://schemas.openxmlformats.org/presentationml/2006/main" xmlns:r="http://schemas.openxmlformats.org/officeDocument/2006/relationships">
+<file path=ppt/notesSlides/notesSlide2.xml><?xml version="1.0" encoding="utf-8"?>
+<p:notes xmlns:a="http://schemas.openxmlformats.org/drawingml/2006/main" xmlns:r="http://schemas.openxmlformats.org/officeDocument/2006/relationships" xmlns:p="http://schemas.openxmlformats.org/presentationml/2006/main">
   <p:cSld>
     <p:spTree>
       <p:nvGrpSpPr>
@@ -374,7 +376,7 @@
         <p:nvSpPr>
           <p:cNvPr id="2" name="Slide Image Placeholder 1"/>
           <p:cNvSpPr>
-            <a:spLocks noGrp="1"/>
+            <a:spLocks noGrp="1" noRot="1" noChangeAspect="1"/>
           </p:cNvSpPr>
           <p:nvPr>
             <p:ph type="sldImg" idx="2"/>
@@ -389,14 +391,16 @@
             <a:spLocks noGrp="1"/>
           </p:cNvSpPr>
           <p:nvPr>
-            <p:ph type="body" idx="3" sz="quarter"/>
+            <p:ph type="body" sz="quarter" idx="3"/>
           </p:nvPr>
         </p:nvSpPr>
         <p:spPr/>
         <p:txBody>
           <a:bodyPr/>
           <a:lstStyle/>
-          <a:p/>
+          <a:p>
+            <a:endParaRPr/>
+          </a:p>
         </p:txBody>
       </p:sp>
       <p:sp>
@@ -406,7 +410,7 @@
             <a:spLocks noGrp="1"/>
           </p:cNvSpPr>
           <p:nvPr>
-            <p:ph type="sldNum" idx="5" sz="quarter"/>
+            <p:ph type="sldNum" sz="quarter" idx="5"/>
           </p:nvPr>
         </p:nvSpPr>
         <p:spPr/>
@@ -571,7 +575,7 @@
           <a:lstStyle/>
           <a:p>
             <a:fld id="{760FBDFE-C587-4B4C-A407-44438C67B59E}" type="datetimeFigureOut">
-              <a:t>2026-10-15</a:t>
+              <a:t>2026-10-21</a:t>
             </a:fld>
             <a:endParaRPr/>
           </a:p>
@@ -677,7 +681,7 @@
           <a:lstStyle/>
           <a:p>
             <a:fld id="{760FBDFE-C587-4B4C-A407-44438C67B59E}" type="datetimeFigureOut">
-              <a:t>2026-10-15</a:t>
+              <a:t>2026-10-21</a:t>
             </a:fld>
             <a:endParaRPr/>
           </a:p>
@@ -850,7 +854,7 @@
           <a:lstStyle/>
           <a:p>
             <a:fld id="{760FBDFE-C587-4B4C-A407-44438C67B59E}" type="datetimeFigureOut">
-              <a:t>2026-10-15</a:t>
+              <a:t>2026-10-21</a:t>
             </a:fld>
             <a:endParaRPr/>
           </a:p>
@@ -4682,7 +4686,7 @@
           <a:lstStyle/>
           <a:p>
             <a:fld id="{760FBDFE-C587-4B4C-A407-44438C67B59E}" type="datetimeFigureOut">
-              <a:t>2026-10-15</a:t>
+              <a:t>2026-10-21</a:t>
             </a:fld>
             <a:endParaRPr/>
           </a:p>
@@ -4956,7 +4960,7 @@
           <a:lstStyle/>
           <a:p>
             <a:fld id="{760FBDFE-C587-4B4C-A407-44438C67B59E}" type="datetimeFigureOut">
-              <a:t>2026-10-15</a:t>
+              <a:t>2026-10-21</a:t>
             </a:fld>
             <a:endParaRPr/>
           </a:p>
@@ -5237,7 +5241,7 @@
           <a:lstStyle/>
           <a:p>
             <a:fld id="{760FBDFE-C587-4B4C-A407-44438C67B59E}" type="datetimeFigureOut">
-              <a:t>2026-10-15</a:t>
+              <a:t>2026-10-21</a:t>
             </a:fld>
             <a:endParaRPr/>
           </a:p>
@@ -5686,7 +5690,7 @@
           <a:lstStyle/>
           <a:p>
             <a:fld id="{760FBDFE-C587-4B4C-A407-44438C67B59E}" type="datetimeFigureOut">
-              <a:t>2026-10-15</a:t>
+              <a:t>2026-10-21</a:t>
             </a:fld>
             <a:endParaRPr/>
           </a:p>
@@ -5829,7 +5833,7 @@
           <a:lstStyle/>
           <a:p>
             <a:fld id="{760FBDFE-C587-4B4C-A407-44438C67B59E}" type="datetimeFigureOut">
-              <a:t>2026-10-15</a:t>
+              <a:t>2026-10-21</a:t>
             </a:fld>
             <a:endParaRPr/>
           </a:p>
@@ -5935,7 +5939,7 @@
           <a:lstStyle/>
           <a:p>
             <a:fld id="{760FBDFE-C587-4B4C-A407-44438C67B59E}" type="datetimeFigureOut">
-              <a:t>2026-10-15</a:t>
+              <a:t>2026-10-21</a:t>
             </a:fld>
             <a:endParaRPr/>
           </a:p>
@@ -6123,7 +6127,7 @@
           <a:lstStyle/>
           <a:p>
             <a:fld id="{9EFD9D74-47D9-4702-A33C-335B63B48DBF}" type="datetimeFigureOut">
-              <a:t>2026-10-15</a:t>
+              <a:t>2026-10-21</a:t>
             </a:fld>
             <a:endParaRPr/>
           </a:p>
@@ -6389,7 +6393,7 @@
           <a:lstStyle/>
           <a:p>
             <a:fld id="{760FBDFE-C587-4B4C-A407-44438C67B59E}" type="datetimeFigureOut">
-              <a:t>2026-10-15</a:t>
+              <a:t>2026-10-21</a:t>
             </a:fld>
             <a:endParaRPr/>
           </a:p>
@@ -6630,7 +6634,7 @@
           </a:lstStyle>
           <a:p>
             <a:fld id="{760FBDFE-C587-4B4C-A407-44438C67B59E}" type="datetimeFigureOut">
-              <a:t>2026-10-15</a:t>
+              <a:t>2026-10-21</a:t>
             </a:fld>
             <a:endParaRPr/>
           </a:p>
@@ -7060,7 +7064,7 @@
 </file>
 
 <file path=ppt/slides/slide1.xml><?xml version="1.0" encoding="utf-8"?>
-<p:sld xmlns:a="http://schemas.openxmlformats.org/drawingml/2006/main" xmlns:p="http://schemas.openxmlformats.org/presentationml/2006/main" xmlns:r="http://schemas.openxmlformats.org/officeDocument/2006/relationships">
+<p:sld xmlns:a="http://schemas.openxmlformats.org/drawingml/2006/main" xmlns:r="http://schemas.openxmlformats.org/officeDocument/2006/relationships" xmlns:p="http://schemas.openxmlformats.org/presentationml/2006/main">
   <p:cSld>
     <p:spTree>
       <p:nvGrpSpPr>
@@ -7068,7 +7072,14 @@
         <p:cNvGrpSpPr/>
         <p:nvPr/>
       </p:nvGrpSpPr>
-      <p:grpSpPr/>
+      <p:grpSpPr>
+        <a:xfrm>
+          <a:off x="0" y="0"/>
+          <a:ext cx="0" cy="0"/>
+          <a:chOff x="0" y="0"/>
+          <a:chExt cx="0" cy="0"/>
+        </a:xfrm>
+      </p:grpSpPr>
       <p:sp>
         <p:nvSpPr>
           <p:cNvPr id="2" name="TextBox 1"/>
@@ -7078,7 +7089,7 @@
         <p:spPr>
           <a:xfrm>
             <a:off x="667512" y="283464"/>
-            <a:ext cx="10058400" cy="493776"/>
+            <a:ext cx="10058400" cy="438582"/>
           </a:xfrm>
           <a:prstGeom prst="rect">
             <a:avLst/>
@@ -7086,21 +7097,27 @@
           <a:noFill/>
         </p:spPr>
         <p:txBody>
-          <a:bodyPr wrap="square" lIns="0" rIns="0" tIns="0" bIns="0">
+          <a:bodyPr wrap="square" lIns="0" tIns="0" rIns="0" bIns="0">
             <a:spAutoFit/>
           </a:bodyPr>
           <a:lstStyle/>
           <a:p>
             <a:pPr algn="l"/>
             <a:r>
-              <a:rPr sz="2850" b="1">
+              <a:rPr sz="2850" b="1" dirty="0" err="1">
                 <a:solidFill>
                   <a:srgbClr val="0D569A"/>
                 </a:solidFill>
                 <a:latin typeface="Microsoft YaHei"/>
               </a:rPr>
-              <a:t>FlashReFocus：单张照片的交互式重对焦</a:t>
-            </a:r>
+              <a:t>FlashReFocus</a:t>
+            </a:r>
+            <a:endParaRPr sz="2850" b="1" dirty="0">
+              <a:solidFill>
+                <a:srgbClr val="0D569A"/>
+              </a:solidFill>
+              <a:latin typeface="Microsoft YaHei"/>
+            </a:endParaRPr>
           </a:p>
         </p:txBody>
       </p:sp>
@@ -7121,20 +7138,29 @@
           <a:noFill/>
         </p:spPr>
         <p:txBody>
-          <a:bodyPr wrap="square" lIns="0" rIns="0" tIns="0" bIns="0">
+          <a:bodyPr wrap="square" lIns="0" tIns="0" rIns="0" bIns="0">
             <a:spAutoFit/>
           </a:bodyPr>
           <a:lstStyle/>
           <a:p>
             <a:pPr algn="l"/>
             <a:r>
-              <a:rPr sz="1800" b="0">
+              <a:rPr sz="1800" b="0" dirty="0" err="1">
                 <a:solidFill>
                   <a:srgbClr val="101F37"/>
                 </a:solidFill>
                 <a:latin typeface="Microsoft YaHei"/>
               </a:rPr>
-              <a:t>先恢复一张清晰图，再选择对焦主体或背景；同一照片可反复调整。</a:t>
+              <a:t>先恢复一张清晰图，再选择对焦主体或背景；同一照片可反复调整</a:t>
+            </a:r>
+            <a:r>
+              <a:rPr sz="1800" b="0" dirty="0">
+                <a:solidFill>
+                  <a:srgbClr val="101F37"/>
+                </a:solidFill>
+                <a:latin typeface="Microsoft YaHei"/>
+              </a:rPr>
+              <a:t>。</a:t>
             </a:r>
           </a:p>
         </p:txBody>
@@ -7156,7 +7182,7 @@
           <a:noFill/>
         </p:spPr>
         <p:txBody>
-          <a:bodyPr wrap="square" lIns="0" rIns="0" tIns="0" bIns="0">
+          <a:bodyPr wrap="square" lIns="0" tIns="0" rIns="0" bIns="0">
             <a:spAutoFit/>
           </a:bodyPr>
           <a:lstStyle/>
@@ -7239,7 +7265,7 @@
           <a:noFill/>
         </p:spPr>
         <p:txBody>
-          <a:bodyPr wrap="square" lIns="0" rIns="0" tIns="0" bIns="0">
+          <a:bodyPr wrap="square" lIns="0" tIns="0" rIns="0" bIns="0">
             <a:spAutoFit/>
           </a:bodyPr>
           <a:lstStyle/>
@@ -7322,7 +7348,7 @@
           <a:noFill/>
         </p:spPr>
         <p:txBody>
-          <a:bodyPr wrap="square" lIns="0" rIns="0" tIns="0" bIns="0">
+          <a:bodyPr wrap="square" lIns="0" tIns="0" rIns="0" bIns="0">
             <a:spAutoFit/>
           </a:bodyPr>
           <a:lstStyle/>
@@ -7405,7 +7431,7 @@
           <a:noFill/>
         </p:spPr>
         <p:txBody>
-          <a:bodyPr wrap="square" lIns="0" rIns="0" tIns="0" bIns="0">
+          <a:bodyPr wrap="square" lIns="0" tIns="0" rIns="0" bIns="0">
             <a:spAutoFit/>
           </a:bodyPr>
           <a:lstStyle/>
@@ -7488,90 +7514,29 @@
           <a:noFill/>
         </p:spPr>
         <p:txBody>
-          <a:bodyPr wrap="square" lIns="0" rIns="0" tIns="0" bIns="0">
+          <a:bodyPr wrap="square" lIns="0" tIns="0" rIns="0" bIns="0">
             <a:spAutoFit/>
           </a:bodyPr>
           <a:lstStyle/>
           <a:p>
             <a:pPr algn="l"/>
             <a:r>
-              <a:rPr sz="1800" b="0">
+              <a:rPr sz="1800" b="0" dirty="0" err="1">
                 <a:solidFill>
                   <a:srgbClr val="101F37"/>
                 </a:solidFill>
                 <a:latin typeface="Microsoft YaHei"/>
               </a:rPr>
-              <a:t>更换焦点时只运行轻量渲染器，无需再次恢复整张图像。</a:t>
-            </a:r>
-          </a:p>
-        </p:txBody>
-      </p:sp>
-      <p:sp>
-        <p:nvSpPr>
-          <p:cNvPr id="19" name="TextBox 18"/>
-          <p:cNvSpPr txBox="1"/>
-          <p:nvPr/>
-        </p:nvSpPr>
-        <p:spPr>
-          <a:xfrm>
-            <a:off x="777240" y="5916168"/>
-            <a:ext cx="10652760" cy="274320"/>
-          </a:xfrm>
-          <a:prstGeom prst="rect">
-            <a:avLst/>
-          </a:prstGeom>
-          <a:noFill/>
-        </p:spPr>
-        <p:txBody>
-          <a:bodyPr wrap="square" lIns="0" rIns="0" tIns="0" bIns="0">
-            <a:spAutoFit/>
-          </a:bodyPr>
-          <a:lstStyle/>
-          <a:p>
-            <a:pPr algn="l"/>
-            <a:r>
-              <a:rPr sz="1400" b="0">
-                <a:solidFill>
-                  <a:srgbClr val="5B6D82"/>
+              <a:t>更换焦点时只运行轻量渲染器，无需再次恢复整张图像</a:t>
+            </a:r>
+            <a:r>
+              <a:rPr sz="1800" b="0" dirty="0">
+                <a:solidFill>
+                  <a:srgbClr val="101F37"/>
                 </a:solidFill>
                 <a:latin typeface="Microsoft YaHei"/>
               </a:rPr>
-              <a:t>当前为论文效果展示；专用权重待公开，本地复现尚未开始。</a:t>
-            </a:r>
-          </a:p>
-        </p:txBody>
-      </p:sp>
-      <p:sp>
-        <p:nvSpPr>
-          <p:cNvPr id="20" name="TextBox 19"/>
-          <p:cNvSpPr txBox="1"/>
-          <p:nvPr/>
-        </p:nvSpPr>
-        <p:spPr>
-          <a:xfrm>
-            <a:off x="777240" y="6254496"/>
-            <a:ext cx="10652760" cy="182880"/>
-          </a:xfrm>
-          <a:prstGeom prst="rect">
-            <a:avLst/>
-          </a:prstGeom>
-          <a:noFill/>
-        </p:spPr>
-        <p:txBody>
-          <a:bodyPr wrap="square" lIns="0" rIns="0" tIns="0" bIns="0">
-            <a:spAutoFit/>
-          </a:bodyPr>
-          <a:lstStyle/>
-          <a:p>
-            <a:pPr algn="l"/>
-            <a:r>
-              <a:rPr sz="900" b="0">
-                <a:solidFill>
-                  <a:srgbClr val="5B6D82"/>
-                </a:solidFill>
-                <a:latin typeface="Microsoft YaHei"/>
-              </a:rPr>
-              <a:t>图源：FlashReFocus，Fig. H.11（第 1、3 行）；绿点表示所选焦点。arXiv:2610.23297v1</a:t>
+              <a:t>。</a:t>
             </a:r>
           </a:p>
         </p:txBody>
@@ -7585,7 +7550,7 @@
 </file>
 
 <file path=ppt/slides/slide2.xml><?xml version="1.0" encoding="utf-8"?>
-<p:sld xmlns:a="http://schemas.openxmlformats.org/drawingml/2006/main" xmlns:p="http://schemas.openxmlformats.org/presentationml/2006/main" xmlns:r="http://schemas.openxmlformats.org/officeDocument/2006/relationships">
+<p:sld xmlns:a="http://schemas.openxmlformats.org/drawingml/2006/main" xmlns:r="http://schemas.openxmlformats.org/officeDocument/2006/relationships" xmlns:p="http://schemas.openxmlformats.org/presentationml/2006/main">
   <p:cSld>
     <p:spTree>
       <p:nvGrpSpPr>
@@ -7593,7 +7558,14 @@
         <p:cNvGrpSpPr/>
         <p:nvPr/>
       </p:nvGrpSpPr>
-      <p:grpSpPr/>
+      <p:grpSpPr>
+        <a:xfrm>
+          <a:off x="0" y="0"/>
+          <a:ext cx="0" cy="0"/>
+          <a:chOff x="0" y="0"/>
+          <a:chExt cx="0" cy="0"/>
+        </a:xfrm>
+      </p:grpSpPr>
       <p:sp>
         <p:nvSpPr>
           <p:cNvPr id="2" name="TextBox 1"/>
@@ -7603,7 +7575,7 @@
         <p:spPr>
           <a:xfrm>
             <a:off x="667512" y="283464"/>
-            <a:ext cx="10058400" cy="493776"/>
+            <a:ext cx="10058400" cy="438582"/>
           </a:xfrm>
           <a:prstGeom prst="rect">
             <a:avLst/>
@@ -7611,21 +7583,27 @@
           <a:noFill/>
         </p:spPr>
         <p:txBody>
-          <a:bodyPr wrap="square" lIns="0" rIns="0" tIns="0" bIns="0">
+          <a:bodyPr wrap="square" lIns="0" tIns="0" rIns="0" bIns="0">
             <a:spAutoFit/>
           </a:bodyPr>
           <a:lstStyle/>
           <a:p>
             <a:pPr algn="l"/>
             <a:r>
-              <a:rPr sz="2850" b="1">
+              <a:rPr sz="2850" b="1" dirty="0" err="1">
                 <a:solidFill>
                   <a:srgbClr val="0D569A"/>
                 </a:solidFill>
                 <a:latin typeface="Microsoft YaHei"/>
               </a:rPr>
-              <a:t>方法原理：先恢复清晰，再按深度渲染</a:t>
-            </a:r>
+              <a:t>原理</a:t>
+            </a:r>
+            <a:endParaRPr sz="2850" b="1" dirty="0">
+              <a:solidFill>
+                <a:srgbClr val="0D569A"/>
+              </a:solidFill>
+              <a:latin typeface="Microsoft YaHei"/>
+            </a:endParaRPr>
           </a:p>
         </p:txBody>
       </p:sp>
@@ -7646,7 +7624,7 @@
           <a:noFill/>
         </p:spPr>
         <p:txBody>
-          <a:bodyPr wrap="square" lIns="0" rIns="0" tIns="0" bIns="0">
+          <a:bodyPr wrap="square" lIns="0" tIns="0" rIns="0" bIns="0">
             <a:spAutoFit/>
           </a:bodyPr>
           <a:lstStyle/>
@@ -7697,7 +7675,7 @@
         <p:spPr>
           <a:xfrm>
             <a:off x="777240" y="5934456"/>
-            <a:ext cx="10652760" cy="329184"/>
+            <a:ext cx="6943645" cy="261610"/>
           </a:xfrm>
           <a:prstGeom prst="rect">
             <a:avLst/>
@@ -7705,20 +7683,29 @@
           <a:noFill/>
         </p:spPr>
         <p:txBody>
-          <a:bodyPr wrap="square" lIns="0" rIns="0" tIns="0" bIns="0">
+          <a:bodyPr wrap="square" lIns="0" tIns="0" rIns="0" bIns="0">
             <a:spAutoFit/>
           </a:bodyPr>
           <a:lstStyle/>
           <a:p>
             <a:pPr algn="l"/>
             <a:r>
-              <a:rPr sz="1700" b="0">
+              <a:rPr sz="1700" b="0" dirty="0" err="1">
                 <a:solidFill>
                   <a:srgbClr val="101F37"/>
                 </a:solidFill>
                 <a:latin typeface="Microsoft YaHei"/>
               </a:rPr>
-              <a:t>注意力偏向离焦程度相近的位置；深度估计偏差仍会影响虚化结果。</a:t>
+              <a:t>注意力偏向离焦程度相近的位置；深度估计偏差仍会影响虚化结果</a:t>
+            </a:r>
+            <a:r>
+              <a:rPr sz="1700" b="0" dirty="0">
+                <a:solidFill>
+                  <a:srgbClr val="101F37"/>
+                </a:solidFill>
+                <a:latin typeface="Microsoft YaHei"/>
+              </a:rPr>
+              <a:t>。</a:t>
             </a:r>
           </a:p>
         </p:txBody>
@@ -7732,7 +7719,7 @@
         <p:spPr>
           <a:xfrm>
             <a:off x="777240" y="6300216"/>
-            <a:ext cx="10652760" cy="182880"/>
+            <a:ext cx="5318760" cy="138499"/>
           </a:xfrm>
           <a:prstGeom prst="rect">
             <a:avLst/>
@@ -7740,20 +7727,47 @@
           <a:noFill/>
         </p:spPr>
         <p:txBody>
-          <a:bodyPr wrap="square" lIns="0" rIns="0" tIns="0" bIns="0">
+          <a:bodyPr wrap="square" lIns="0" tIns="0" rIns="0" bIns="0">
             <a:spAutoFit/>
           </a:bodyPr>
           <a:lstStyle/>
           <a:p>
             <a:pPr algn="l"/>
             <a:r>
-              <a:rPr sz="900" b="0">
+              <a:rPr sz="900" b="0" dirty="0" err="1">
                 <a:solidFill>
                   <a:srgbClr val="5B6D82"/>
                 </a:solidFill>
                 <a:latin typeface="Microsoft YaHei"/>
               </a:rPr>
-              <a:t>图源：FlashReFocus，Fig. 2（裁去训练图例）；流程解释见讲稿。</a:t>
+              <a:t>图源：FlashReFocus，Fig</a:t>
+            </a:r>
+            <a:r>
+              <a:rPr sz="900" b="0" dirty="0">
+                <a:solidFill>
+                  <a:srgbClr val="5B6D82"/>
+                </a:solidFill>
+                <a:latin typeface="Microsoft YaHei"/>
+              </a:rPr>
+              <a:t>. 2（裁去训练图例）；</a:t>
+            </a:r>
+            <a:r>
+              <a:rPr sz="900" b="0" dirty="0" err="1">
+                <a:solidFill>
+                  <a:srgbClr val="5B6D82"/>
+                </a:solidFill>
+                <a:latin typeface="Microsoft YaHei"/>
+              </a:rPr>
+              <a:t>流程解释见讲稿</a:t>
+            </a:r>
+            <a:r>
+              <a:rPr sz="900" b="0" dirty="0">
+                <a:solidFill>
+                  <a:srgbClr val="5B6D82"/>
+                </a:solidFill>
+                <a:latin typeface="Microsoft YaHei"/>
+              </a:rPr>
+              <a:t>。</a:t>
             </a:r>
           </a:p>
         </p:txBody>

</xml_diff>

<commit_message>
report: add three ATB progress slides to 1023 deck
Page 1 fills MPI-label invariance vs CoC response (B36, 10-21 record);
pages 2-3 reserve slots for CoC-VAE fine-structure and B36 full-25 runs.
Speech gains matching sections; FlashReFocus pages renumbered to 4-5.

Co-Authored-By: Claude Opus 5.5 (1M context) <noreply@anthropic.com>
</commit_message>
<xml_diff>
--- a/汇报/2026-10-23_ATB进展与FlashReFocus/FlashReFocus_论文介绍_1023.pptx
+++ b/汇报/2026-10-23_ATB进展与FlashReFocus/FlashReFocus_论文介绍_1023.pptx
@@ -8,6 +8,9 @@
     <p:notesMasterId r:id="rId4"/>
   </p:notesMasterIdLst>
   <p:sldIdLst>
+    <p:sldId id="259" r:id="rId9"/>
+    <p:sldId id="260" r:id="rId10"/>
+    <p:sldId id="261" r:id="rId11"/>
     <p:sldId id="257" r:id="rId2"/>
     <p:sldId id="258" r:id="rId3"/>
   </p:sldIdLst>
@@ -7768,6 +7771,2229 @@
                 <a:latin typeface="Microsoft YaHei"/>
               </a:rPr>
               <a:t>。</a:t>
+            </a:r>
+          </a:p>
+        </p:txBody>
+      </p:sp>
+    </p:spTree>
+  </p:cSld>
+  <p:clrMapOvr>
+    <a:masterClrMapping/>
+  </p:clrMapOvr>
+</p:sld>
+</file>
+
+<file path=ppt/slides/slide3.xml><?xml version="1.0" encoding="utf-8"?>
+<p:sld xmlns:a="http://schemas.openxmlformats.org/drawingml/2006/main" xmlns:p="http://schemas.openxmlformats.org/presentationml/2006/main" xmlns:r="http://schemas.openxmlformats.org/officeDocument/2006/relationships">
+  <p:cSld>
+    <p:spTree>
+      <p:nvGrpSpPr>
+        <p:cNvPr id="1" name=""/>
+        <p:cNvGrpSpPr/>
+        <p:nvPr/>
+      </p:nvGrpSpPr>
+      <p:grpSpPr/>
+      <p:sp>
+        <p:nvSpPr>
+          <p:cNvPr id="2" name="TextBox 1"/>
+          <p:cNvSpPr txBox="1"/>
+          <p:nvPr/>
+        </p:nvSpPr>
+        <p:spPr>
+          <a:xfrm>
+            <a:off x="667512" y="283464"/>
+            <a:ext cx="10058400" cy="438912"/>
+          </a:xfrm>
+          <a:prstGeom prst="rect">
+            <a:avLst/>
+          </a:prstGeom>
+          <a:noFill/>
+        </p:spPr>
+        <p:txBody>
+          <a:bodyPr wrap="square">
+            <a:spAutoFit/>
+          </a:bodyPr>
+          <a:lstStyle/>
+          <a:p>
+            <a:pPr algn="l"/>
+            <a:r>
+              <a:rPr sz="2850" b="1">
+                <a:solidFill>
+                  <a:srgbClr val="0D569A"/>
+                </a:solidFill>
+                <a:latin typeface="Microsoft YaHei"/>
+              </a:rPr>
+              <a:t>ATB 条件核验：几何只经离焦图起作用</a:t>
+            </a:r>
+          </a:p>
+        </p:txBody>
+      </p:sp>
+      <p:sp>
+        <p:nvSpPr>
+          <p:cNvPr id="3" name="TextBox 2"/>
+          <p:cNvSpPr txBox="1"/>
+          <p:nvPr/>
+        </p:nvSpPr>
+        <p:spPr>
+          <a:xfrm>
+            <a:off x="777240" y="5522976"/>
+            <a:ext cx="10652760" cy="329184"/>
+          </a:xfrm>
+          <a:prstGeom prst="rect">
+            <a:avLst/>
+          </a:prstGeom>
+          <a:noFill/>
+        </p:spPr>
+        <p:txBody>
+          <a:bodyPr wrap="square">
+            <a:spAutoFit/>
+          </a:bodyPr>
+          <a:lstStyle/>
+          <a:p>
+            <a:pPr algn="l"/>
+            <a:r>
+              <a:rPr sz="1800" b="0">
+                <a:solidFill>
+                  <a:srgbClr val="101F37"/>
+                </a:solidFill>
+                <a:latin typeface="Microsoft YaHei"/>
+              </a:rPr>
+              <a:t>分区标签改成全 0 / 全 3，输出逐位不变；只改离焦图，鸭头即有响应。</a:t>
+            </a:r>
+          </a:p>
+        </p:txBody>
+      </p:sp>
+      <p:graphicFrame>
+        <p:nvGraphicFramePr>
+          <p:cNvPr id="4" name="Table 3"/>
+          <p:cNvGraphicFramePr>
+            <a:graphicFrameLocks noGrp="1"/>
+          </p:cNvGraphicFramePr>
+          <p:nvPr/>
+        </p:nvGraphicFramePr>
+        <p:xfrm>
+          <a:off x="777240" y="1417320"/>
+          <a:ext cx="6309360" cy="2834640"/>
+        </p:xfrm>
+        <a:graphic>
+          <a:graphicData uri="http://schemas.openxmlformats.org/drawingml/2006/table">
+            <a:tbl>
+              <a:tblPr firstRow="1" bandRow="1">
+                <a:tableStyleId>{5C22544A-7EE6-4342-B048-85BDC9FD1C3A}</a:tableStyleId>
+              </a:tblPr>
+              <a:tblGrid>
+                <a:gridCol w="1600200"/>
+                <a:gridCol w="1965960"/>
+                <a:gridCol w="1600200"/>
+                <a:gridCol w="1143000"/>
+              </a:tblGrid>
+              <a:tr h="566928">
+                <a:tc>
+                  <a:txBody>
+                    <a:bodyPr/>
+                    <a:lstStyle/>
+                    <a:p>
+                      <a:pPr algn="ctr"/>
+                      <a:r>
+                        <a:rPr sz="1500" b="1">
+                          <a:solidFill>
+                            <a:srgbClr val="FFFFFF"/>
+                          </a:solidFill>
+                          <a:latin typeface="Microsoft YaHei"/>
+                        </a:rPr>
+                        <a:t>条件</a:t>
+                      </a:r>
+                    </a:p>
+                  </a:txBody>
+                  <a:tcPr anchor="ctr">
+                    <a:solidFill>
+                      <a:srgbClr val="0D569A"/>
+                    </a:solidFill>
+                  </a:tcPr>
+                </a:tc>
+                <a:tc>
+                  <a:txBody>
+                    <a:bodyPr/>
+                    <a:lstStyle/>
+                    <a:p>
+                      <a:pPr algn="ctr"/>
+                      <a:r>
+                        <a:rPr sz="1500" b="1">
+                          <a:solidFill>
+                            <a:srgbClr val="FFFFFF"/>
+                          </a:solidFill>
+                          <a:latin typeface="Microsoft YaHei"/>
+                        </a:rPr>
+                        <a:t>改动内容</a:t>
+                      </a:r>
+                    </a:p>
+                  </a:txBody>
+                  <a:tcPr anchor="ctr">
+                    <a:solidFill>
+                      <a:srgbClr val="0D569A"/>
+                    </a:solidFill>
+                  </a:tcPr>
+                </a:tc>
+                <a:tc>
+                  <a:txBody>
+                    <a:bodyPr/>
+                    <a:lstStyle/>
+                    <a:p>
+                      <a:pPr algn="ctr"/>
+                      <a:r>
+                        <a:rPr sz="1500" b="1">
+                          <a:solidFill>
+                            <a:srgbClr val="FFFFFF"/>
+                          </a:solidFill>
+                          <a:latin typeface="Microsoft YaHei"/>
+                        </a:rPr>
+                        <a:t>输出不同字节数</a:t>
+                      </a:r>
+                    </a:p>
+                  </a:txBody>
+                  <a:tcPr anchor="ctr">
+                    <a:solidFill>
+                      <a:srgbClr val="0D569A"/>
+                    </a:solidFill>
+                  </a:tcPr>
+                </a:tc>
+                <a:tc>
+                  <a:txBody>
+                    <a:bodyPr/>
+                    <a:lstStyle/>
+                    <a:p>
+                      <a:pPr algn="ctr"/>
+                      <a:r>
+                        <a:rPr sz="1500" b="1">
+                          <a:solidFill>
+                            <a:srgbClr val="FFFFFF"/>
+                          </a:solidFill>
+                          <a:latin typeface="Microsoft YaHei"/>
+                        </a:rPr>
+                        <a:t>受影响帧</a:t>
+                      </a:r>
+                    </a:p>
+                  </a:txBody>
+                  <a:tcPr anchor="ctr">
+                    <a:solidFill>
+                      <a:srgbClr val="0D569A"/>
+                    </a:solidFill>
+                  </a:tcPr>
+                </a:tc>
+              </a:tr>
+              <a:tr h="566928">
+                <a:tc>
+                  <a:txBody>
+                    <a:bodyPr/>
+                    <a:lstStyle/>
+                    <a:p>
+                      <a:pPr algn="ctr"/>
+                      <a:r>
+                        <a:rPr sz="1500" b="0">
+                          <a:solidFill>
+                            <a:srgbClr val="101F37"/>
+                          </a:solidFill>
+                          <a:latin typeface="Microsoft YaHei"/>
+                        </a:rPr>
+                        <a:t>原版重复</a:t>
+                      </a:r>
+                    </a:p>
+                  </a:txBody>
+                  <a:tcPr anchor="ctr">
+                    <a:solidFill>
+                      <a:srgbClr val="FFFFFF"/>
+                    </a:solidFill>
+                  </a:tcPr>
+                </a:tc>
+                <a:tc>
+                  <a:txBody>
+                    <a:bodyPr/>
+                    <a:lstStyle/>
+                    <a:p>
+                      <a:pPr algn="ctr"/>
+                      <a:r>
+                        <a:rPr sz="1500" b="0">
+                          <a:solidFill>
+                            <a:srgbClr val="101F37"/>
+                          </a:solidFill>
+                          <a:latin typeface="Microsoft YaHei"/>
+                        </a:rPr>
+                        <a:t>无</a:t>
+                      </a:r>
+                    </a:p>
+                  </a:txBody>
+                  <a:tcPr anchor="ctr">
+                    <a:solidFill>
+                      <a:srgbClr val="FFFFFF"/>
+                    </a:solidFill>
+                  </a:tcPr>
+                </a:tc>
+                <a:tc>
+                  <a:txBody>
+                    <a:bodyPr/>
+                    <a:lstStyle/>
+                    <a:p>
+                      <a:pPr algn="ctr"/>
+                      <a:r>
+                        <a:rPr sz="1500" b="0">
+                          <a:solidFill>
+                            <a:srgbClr val="101F37"/>
+                          </a:solidFill>
+                          <a:latin typeface="Microsoft YaHei"/>
+                        </a:rPr>
+                        <a:t>0</a:t>
+                      </a:r>
+                    </a:p>
+                  </a:txBody>
+                  <a:tcPr anchor="ctr">
+                    <a:solidFill>
+                      <a:srgbClr val="FFFFFF"/>
+                    </a:solidFill>
+                  </a:tcPr>
+                </a:tc>
+                <a:tc>
+                  <a:txBody>
+                    <a:bodyPr/>
+                    <a:lstStyle/>
+                    <a:p>
+                      <a:pPr algn="ctr"/>
+                      <a:r>
+                        <a:rPr sz="1500" b="0">
+                          <a:solidFill>
+                            <a:srgbClr val="101F37"/>
+                          </a:solidFill>
+                          <a:latin typeface="Microsoft YaHei"/>
+                        </a:rPr>
+                        <a:t>无</a:t>
+                      </a:r>
+                    </a:p>
+                  </a:txBody>
+                  <a:tcPr anchor="ctr">
+                    <a:solidFill>
+                      <a:srgbClr val="FFFFFF"/>
+                    </a:solidFill>
+                  </a:tcPr>
+                </a:tc>
+              </a:tr>
+              <a:tr h="566928">
+                <a:tc>
+                  <a:txBody>
+                    <a:bodyPr/>
+                    <a:lstStyle/>
+                    <a:p>
+                      <a:pPr algn="ctr"/>
+                      <a:r>
+                        <a:rPr sz="1500" b="0">
+                          <a:solidFill>
+                            <a:srgbClr val="101F37"/>
+                          </a:solidFill>
+                          <a:latin typeface="Microsoft YaHei"/>
+                        </a:rPr>
+                        <a:t>分区标签全 0</a:t>
+                      </a:r>
+                    </a:p>
+                  </a:txBody>
+                  <a:tcPr anchor="ctr">
+                    <a:solidFill>
+                      <a:srgbClr val="EEF5FB"/>
+                    </a:solidFill>
+                  </a:tcPr>
+                </a:tc>
+                <a:tc>
+                  <a:txBody>
+                    <a:bodyPr/>
+                    <a:lstStyle/>
+                    <a:p>
+                      <a:pPr algn="ctr"/>
+                      <a:r>
+                        <a:rPr sz="1500" b="0">
+                          <a:solidFill>
+                            <a:srgbClr val="101F37"/>
+                          </a:solidFill>
+                          <a:latin typeface="Microsoft YaHei"/>
+                        </a:rPr>
+                        <a:t>仅 MPI 标签</a:t>
+                      </a:r>
+                    </a:p>
+                  </a:txBody>
+                  <a:tcPr anchor="ctr">
+                    <a:solidFill>
+                      <a:srgbClr val="EEF5FB"/>
+                    </a:solidFill>
+                  </a:tcPr>
+                </a:tc>
+                <a:tc>
+                  <a:txBody>
+                    <a:bodyPr/>
+                    <a:lstStyle/>
+                    <a:p>
+                      <a:pPr algn="ctr"/>
+                      <a:r>
+                        <a:rPr sz="1500" b="0">
+                          <a:solidFill>
+                            <a:srgbClr val="101F37"/>
+                          </a:solidFill>
+                          <a:latin typeface="Microsoft YaHei"/>
+                        </a:rPr>
+                        <a:t>0</a:t>
+                      </a:r>
+                    </a:p>
+                  </a:txBody>
+                  <a:tcPr anchor="ctr">
+                    <a:solidFill>
+                      <a:srgbClr val="EEF5FB"/>
+                    </a:solidFill>
+                  </a:tcPr>
+                </a:tc>
+                <a:tc>
+                  <a:txBody>
+                    <a:bodyPr/>
+                    <a:lstStyle/>
+                    <a:p>
+                      <a:pPr algn="ctr"/>
+                      <a:r>
+                        <a:rPr sz="1500" b="0">
+                          <a:solidFill>
+                            <a:srgbClr val="101F37"/>
+                          </a:solidFill>
+                          <a:latin typeface="Microsoft YaHei"/>
+                        </a:rPr>
+                        <a:t>无</a:t>
+                      </a:r>
+                    </a:p>
+                  </a:txBody>
+                  <a:tcPr anchor="ctr">
+                    <a:solidFill>
+                      <a:srgbClr val="EEF5FB"/>
+                    </a:solidFill>
+                  </a:tcPr>
+                </a:tc>
+              </a:tr>
+              <a:tr h="566928">
+                <a:tc>
+                  <a:txBody>
+                    <a:bodyPr/>
+                    <a:lstStyle/>
+                    <a:p>
+                      <a:pPr algn="ctr"/>
+                      <a:r>
+                        <a:rPr sz="1500" b="0">
+                          <a:solidFill>
+                            <a:srgbClr val="101F37"/>
+                          </a:solidFill>
+                          <a:latin typeface="Microsoft YaHei"/>
+                        </a:rPr>
+                        <a:t>分区标签全 3</a:t>
+                      </a:r>
+                    </a:p>
+                  </a:txBody>
+                  <a:tcPr anchor="ctr">
+                    <a:solidFill>
+                      <a:srgbClr val="FFFFFF"/>
+                    </a:solidFill>
+                  </a:tcPr>
+                </a:tc>
+                <a:tc>
+                  <a:txBody>
+                    <a:bodyPr/>
+                    <a:lstStyle/>
+                    <a:p>
+                      <a:pPr algn="ctr"/>
+                      <a:r>
+                        <a:rPr sz="1500" b="0">
+                          <a:solidFill>
+                            <a:srgbClr val="101F37"/>
+                          </a:solidFill>
+                          <a:latin typeface="Microsoft YaHei"/>
+                        </a:rPr>
+                        <a:t>仅 MPI 标签</a:t>
+                      </a:r>
+                    </a:p>
+                  </a:txBody>
+                  <a:tcPr anchor="ctr">
+                    <a:solidFill>
+                      <a:srgbClr val="FFFFFF"/>
+                    </a:solidFill>
+                  </a:tcPr>
+                </a:tc>
+                <a:tc>
+                  <a:txBody>
+                    <a:bodyPr/>
+                    <a:lstStyle/>
+                    <a:p>
+                      <a:pPr algn="ctr"/>
+                      <a:r>
+                        <a:rPr sz="1500" b="0">
+                          <a:solidFill>
+                            <a:srgbClr val="101F37"/>
+                          </a:solidFill>
+                          <a:latin typeface="Microsoft YaHei"/>
+                        </a:rPr>
+                        <a:t>0</a:t>
+                      </a:r>
+                    </a:p>
+                  </a:txBody>
+                  <a:tcPr anchor="ctr">
+                    <a:solidFill>
+                      <a:srgbClr val="FFFFFF"/>
+                    </a:solidFill>
+                  </a:tcPr>
+                </a:tc>
+                <a:tc>
+                  <a:txBody>
+                    <a:bodyPr/>
+                    <a:lstStyle/>
+                    <a:p>
+                      <a:pPr algn="ctr"/>
+                      <a:r>
+                        <a:rPr sz="1500" b="0">
+                          <a:solidFill>
+                            <a:srgbClr val="101F37"/>
+                          </a:solidFill>
+                          <a:latin typeface="Microsoft YaHei"/>
+                        </a:rPr>
+                        <a:t>无</a:t>
+                      </a:r>
+                    </a:p>
+                  </a:txBody>
+                  <a:tcPr anchor="ctr">
+                    <a:solidFill>
+                      <a:srgbClr val="FFFFFF"/>
+                    </a:solidFill>
+                  </a:tcPr>
+                </a:tc>
+              </a:tr>
+              <a:tr h="566928">
+                <a:tc>
+                  <a:txBody>
+                    <a:bodyPr/>
+                    <a:lstStyle/>
+                    <a:p>
+                      <a:pPr algn="ctr"/>
+                      <a:r>
+                        <a:rPr sz="1500" b="1">
+                          <a:solidFill>
+                            <a:srgbClr val="101F37"/>
+                          </a:solidFill>
+                          <a:latin typeface="Microsoft YaHei"/>
+                        </a:rPr>
+                        <a:t>仅改离焦图</a:t>
+                      </a:r>
+                    </a:p>
+                  </a:txBody>
+                  <a:tcPr anchor="ctr">
+                    <a:solidFill>
+                      <a:srgbClr val="EEF5FB"/>
+                    </a:solidFill>
+                  </a:tcPr>
+                </a:tc>
+                <a:tc>
+                  <a:txBody>
+                    <a:bodyPr/>
+                    <a:lstStyle/>
+                    <a:p>
+                      <a:pPr algn="ctr"/>
+                      <a:r>
+                        <a:rPr sz="1500" b="1">
+                          <a:solidFill>
+                            <a:srgbClr val="101F37"/>
+                          </a:solidFill>
+                          <a:latin typeface="Microsoft YaHei"/>
+                        </a:rPr>
+                        <a:t>第 0 帧鸭头 CoC</a:t>
+                      </a:r>
+                    </a:p>
+                  </a:txBody>
+                  <a:tcPr anchor="ctr">
+                    <a:solidFill>
+                      <a:srgbClr val="EEF5FB"/>
+                    </a:solidFill>
+                  </a:tcPr>
+                </a:tc>
+                <a:tc>
+                  <a:txBody>
+                    <a:bodyPr/>
+                    <a:lstStyle/>
+                    <a:p>
+                      <a:pPr algn="ctr"/>
+                      <a:r>
+                        <a:rPr sz="1500" b="1">
+                          <a:solidFill>
+                            <a:srgbClr val="101F37"/>
+                          </a:solidFill>
+                          <a:latin typeface="Microsoft YaHei"/>
+                        </a:rPr>
+                        <a:t>1,246,773</a:t>
+                      </a:r>
+                    </a:p>
+                  </a:txBody>
+                  <a:tcPr anchor="ctr">
+                    <a:solidFill>
+                      <a:srgbClr val="EEF5FB"/>
+                    </a:solidFill>
+                  </a:tcPr>
+                </a:tc>
+                <a:tc>
+                  <a:txBody>
+                    <a:bodyPr/>
+                    <a:lstStyle/>
+                    <a:p>
+                      <a:pPr algn="ctr"/>
+                      <a:r>
+                        <a:rPr sz="1500" b="1">
+                          <a:solidFill>
+                            <a:srgbClr val="101F37"/>
+                          </a:solidFill>
+                          <a:latin typeface="Microsoft YaHei"/>
+                        </a:rPr>
+                        <a:t>0–7</a:t>
+                      </a:r>
+                    </a:p>
+                  </a:txBody>
+                  <a:tcPr anchor="ctr">
+                    <a:solidFill>
+                      <a:srgbClr val="EEF5FB"/>
+                    </a:solidFill>
+                  </a:tcPr>
+                </a:tc>
+              </a:tr>
+            </a:tbl>
+          </a:graphicData>
+        </a:graphic>
+      </p:graphicFrame>
+      <p:sp>
+        <p:nvSpPr>
+          <p:cNvPr id="5" name="TextBox 4"/>
+          <p:cNvSpPr txBox="1"/>
+          <p:nvPr/>
+        </p:nvSpPr>
+        <p:spPr>
+          <a:xfrm>
+            <a:off x="7360920" y="1371600"/>
+            <a:ext cx="1325880" cy="274320"/>
+          </a:xfrm>
+          <a:prstGeom prst="rect">
+            <a:avLst/>
+          </a:prstGeom>
+          <a:noFill/>
+        </p:spPr>
+        <p:txBody>
+          <a:bodyPr wrap="square">
+            <a:spAutoFit/>
+          </a:bodyPr>
+          <a:lstStyle/>
+          <a:p>
+            <a:pPr algn="ctr"/>
+            <a:r>
+              <a:rPr sz="1500" b="1">
+                <a:solidFill>
+                  <a:srgbClr val="0D569A"/>
+                </a:solidFill>
+                <a:latin typeface="Microsoft YaHei"/>
+              </a:rPr>
+              <a:t>原图</a:t>
+            </a:r>
+          </a:p>
+        </p:txBody>
+      </p:sp>
+      <p:pic>
+        <p:nvPicPr>
+          <p:cNvPr id="6" name="Picture 5" descr="Input-head-x3.png"/>
+          <p:cNvPicPr>
+            <a:picLocks noChangeAspect="1"/>
+          </p:cNvPicPr>
+          <p:nvPr/>
+        </p:nvPicPr>
+        <p:blipFill>
+          <a:blip r:embed="rId2"/>
+          <a:stretch>
+            <a:fillRect/>
+          </a:stretch>
+        </p:blipFill>
+        <p:spPr>
+          <a:xfrm>
+            <a:off x="7360920" y="1737360"/>
+            <a:ext cx="1325880" cy="1657350"/>
+          </a:xfrm>
+          <a:prstGeom prst="rect">
+            <a:avLst/>
+          </a:prstGeom>
+        </p:spPr>
+      </p:pic>
+      <p:sp>
+        <p:nvSpPr>
+          <p:cNvPr id="7" name="TextBox 6"/>
+          <p:cNvSpPr txBox="1"/>
+          <p:nvPr/>
+        </p:nvSpPr>
+        <p:spPr>
+          <a:xfrm>
+            <a:off x="8778240" y="1371600"/>
+            <a:ext cx="1325880" cy="274320"/>
+          </a:xfrm>
+          <a:prstGeom prst="rect">
+            <a:avLst/>
+          </a:prstGeom>
+          <a:noFill/>
+        </p:spPr>
+        <p:txBody>
+          <a:bodyPr wrap="square">
+            <a:spAutoFit/>
+          </a:bodyPr>
+          <a:lstStyle/>
+          <a:p>
+            <a:pPr algn="ctr"/>
+            <a:r>
+              <a:rPr sz="1500" b="1">
+                <a:solidFill>
+                  <a:srgbClr val="0D569A"/>
+                </a:solidFill>
+                <a:latin typeface="Microsoft YaHei"/>
+              </a:rPr>
+              <a:t>原版</a:t>
+            </a:r>
+          </a:p>
+        </p:txBody>
+      </p:sp>
+      <p:pic>
+        <p:nvPicPr>
+          <p:cNvPr id="8" name="Picture 7" descr="A-head-x3.png"/>
+          <p:cNvPicPr>
+            <a:picLocks noChangeAspect="1"/>
+          </p:cNvPicPr>
+          <p:nvPr/>
+        </p:nvPicPr>
+        <p:blipFill>
+          <a:blip r:embed="rId3"/>
+          <a:stretch>
+            <a:fillRect/>
+          </a:stretch>
+        </p:blipFill>
+        <p:spPr>
+          <a:xfrm>
+            <a:off x="8778240" y="1737360"/>
+            <a:ext cx="1325880" cy="1657350"/>
+          </a:xfrm>
+          <a:prstGeom prst="rect">
+            <a:avLst/>
+          </a:prstGeom>
+        </p:spPr>
+      </p:pic>
+      <p:sp>
+        <p:nvSpPr>
+          <p:cNvPr id="9" name="TextBox 8"/>
+          <p:cNvSpPr txBox="1"/>
+          <p:nvPr/>
+        </p:nvSpPr>
+        <p:spPr>
+          <a:xfrm>
+            <a:off x="10195560" y="1371600"/>
+            <a:ext cx="1325880" cy="274320"/>
+          </a:xfrm>
+          <a:prstGeom prst="rect">
+            <a:avLst/>
+          </a:prstGeom>
+          <a:noFill/>
+        </p:spPr>
+        <p:txBody>
+          <a:bodyPr wrap="square">
+            <a:spAutoFit/>
+          </a:bodyPr>
+          <a:lstStyle/>
+          <a:p>
+            <a:pPr algn="ctr"/>
+            <a:r>
+              <a:rPr sz="1500" b="1">
+                <a:solidFill>
+                  <a:srgbClr val="0D569A"/>
+                </a:solidFill>
+                <a:latin typeface="Microsoft YaHei"/>
+              </a:rPr>
+              <a:t>仅改离焦图</a:t>
+            </a:r>
+          </a:p>
+        </p:txBody>
+      </p:sp>
+      <p:pic>
+        <p:nvPicPr>
+          <p:cNvPr id="10" name="Picture 9" descr="D-head-x3.png"/>
+          <p:cNvPicPr>
+            <a:picLocks noChangeAspect="1"/>
+          </p:cNvPicPr>
+          <p:nvPr/>
+        </p:nvPicPr>
+        <p:blipFill>
+          <a:blip r:embed="rId4"/>
+          <a:stretch>
+            <a:fillRect/>
+          </a:stretch>
+        </p:blipFill>
+        <p:spPr>
+          <a:xfrm>
+            <a:off x="10195560" y="1737360"/>
+            <a:ext cx="1325880" cy="1657350"/>
+          </a:xfrm>
+          <a:prstGeom prst="rect">
+            <a:avLst/>
+          </a:prstGeom>
+        </p:spPr>
+      </p:pic>
+      <p:sp>
+        <p:nvSpPr>
+          <p:cNvPr id="11" name="TextBox 10"/>
+          <p:cNvSpPr txBox="1"/>
+          <p:nvPr/>
+        </p:nvSpPr>
+        <p:spPr>
+          <a:xfrm>
+            <a:off x="7360920" y="3520440"/>
+            <a:ext cx="4160520" cy="274320"/>
+          </a:xfrm>
+          <a:prstGeom prst="rect">
+            <a:avLst/>
+          </a:prstGeom>
+          <a:noFill/>
+        </p:spPr>
+        <p:txBody>
+          <a:bodyPr wrap="square">
+            <a:spAutoFit/>
+          </a:bodyPr>
+          <a:lstStyle/>
+          <a:p>
+            <a:pPr algn="ctr"/>
+            <a:r>
+              <a:rPr sz="1300" b="0">
+                <a:solidFill>
+                  <a:srgbClr val="5B6D82"/>
+                </a:solidFill>
+                <a:latin typeface="Microsoft YaHei"/>
+              </a:rPr>
+              <a:t>mallard-water 第 0 帧鸭头局部</a:t>
+            </a:r>
+          </a:p>
+        </p:txBody>
+      </p:sp>
+    </p:spTree>
+  </p:cSld>
+  <p:clrMapOvr>
+    <a:masterClrMapping/>
+  </p:clrMapOvr>
+</p:sld>
+</file>
+
+<file path=ppt/slides/slide4.xml><?xml version="1.0" encoding="utf-8"?>
+<p:sld xmlns:a="http://schemas.openxmlformats.org/drawingml/2006/main" xmlns:p="http://schemas.openxmlformats.org/presentationml/2006/main" xmlns:r="http://schemas.openxmlformats.org/officeDocument/2006/relationships">
+  <p:cSld>
+    <p:spTree>
+      <p:nvGrpSpPr>
+        <p:cNvPr id="1" name=""/>
+        <p:cNvGrpSpPr/>
+        <p:nvPr/>
+      </p:nvGrpSpPr>
+      <p:grpSpPr/>
+      <p:sp>
+        <p:nvSpPr>
+          <p:cNvPr id="2" name="TextBox 1"/>
+          <p:cNvSpPr txBox="1"/>
+          <p:nvPr/>
+        </p:nvSpPr>
+        <p:spPr>
+          <a:xfrm>
+            <a:off x="667512" y="283464"/>
+            <a:ext cx="10058400" cy="438912"/>
+          </a:xfrm>
+          <a:prstGeom prst="rect">
+            <a:avLst/>
+          </a:prstGeom>
+          <a:noFill/>
+        </p:spPr>
+        <p:txBody>
+          <a:bodyPr wrap="square">
+            <a:spAutoFit/>
+          </a:bodyPr>
+          <a:lstStyle/>
+          <a:p>
+            <a:pPr algn="l"/>
+            <a:r>
+              <a:rPr sz="2850" b="1">
+                <a:solidFill>
+                  <a:srgbClr val="0D569A"/>
+                </a:solidFill>
+                <a:latin typeface="Microsoft YaHei"/>
+              </a:rPr>
+              <a:t>离焦图经 VAE 压缩后，细结构还剩多少</a:t>
+            </a:r>
+          </a:p>
+        </p:txBody>
+      </p:sp>
+      <p:sp>
+        <p:nvSpPr>
+          <p:cNvPr id="3" name="Rectangle 2"/>
+          <p:cNvSpPr/>
+          <p:nvPr/>
+        </p:nvSpPr>
+        <p:spPr>
+          <a:xfrm>
+            <a:off x="777240" y="1188720"/>
+            <a:ext cx="5669280" cy="4114800"/>
+          </a:xfrm>
+          <a:prstGeom prst="rect">
+            <a:avLst/>
+          </a:prstGeom>
+          <a:solidFill>
+            <a:srgbClr val="F5F7FA"/>
+          </a:solidFill>
+          <a:ln>
+            <a:solidFill>
+              <a:srgbClr val="9FB3C8"/>
+            </a:solidFill>
+            <a:prstDash val="dash"/>
+          </a:ln>
+        </p:spPr>
+        <p:style>
+          <a:lnRef idx="1">
+            <a:schemeClr val="accent1"/>
+          </a:lnRef>
+          <a:fillRef idx="3">
+            <a:schemeClr val="accent1"/>
+          </a:fillRef>
+          <a:effectRef idx="2">
+            <a:schemeClr val="accent1"/>
+          </a:effectRef>
+          <a:fontRef idx="minor">
+            <a:schemeClr val="lt1"/>
+          </a:fontRef>
+        </p:style>
+        <p:txBody>
+          <a:bodyPr rtlCol="0" anchor="ctr" wrap="square"/>
+          <a:lstStyle/>
+          <a:p>
+            <a:pPr algn="ctr"/>
+            <a:r>
+              <a:rPr sz="1400">
+                <a:solidFill>
+                  <a:srgbClr val="5B6D82"/>
+                </a:solidFill>
+                <a:latin typeface="Microsoft YaHei"/>
+              </a:rPr>
+              <a:t>线宽 – 响应曲线</a:t>
+            </a:r>
+          </a:p>
+          <a:p>
+            <a:pPr algn="ctr"/>
+            <a:r>
+              <a:rPr sz="1400">
+                <a:solidFill>
+                  <a:srgbClr val="5B6D82"/>
+                </a:solidFill>
+                <a:latin typeface="Microsoft YaHei"/>
+              </a:rPr>
+              <a:t>（1–32 px，待实验结果）</a:t>
+            </a:r>
+          </a:p>
+        </p:txBody>
+      </p:sp>
+      <p:sp>
+        <p:nvSpPr>
+          <p:cNvPr id="4" name="Rectangle 3"/>
+          <p:cNvSpPr/>
+          <p:nvPr/>
+        </p:nvSpPr>
+        <p:spPr>
+          <a:xfrm>
+            <a:off x="6675120" y="1188720"/>
+            <a:ext cx="4754880" cy="1965960"/>
+          </a:xfrm>
+          <a:prstGeom prst="rect">
+            <a:avLst/>
+          </a:prstGeom>
+          <a:solidFill>
+            <a:srgbClr val="F5F7FA"/>
+          </a:solidFill>
+          <a:ln>
+            <a:solidFill>
+              <a:srgbClr val="9FB3C8"/>
+            </a:solidFill>
+            <a:prstDash val="dash"/>
+          </a:ln>
+        </p:spPr>
+        <p:style>
+          <a:lnRef idx="1">
+            <a:schemeClr val="accent1"/>
+          </a:lnRef>
+          <a:fillRef idx="3">
+            <a:schemeClr val="accent1"/>
+          </a:fillRef>
+          <a:effectRef idx="2">
+            <a:schemeClr val="accent1"/>
+          </a:effectRef>
+          <a:fontRef idx="minor">
+            <a:schemeClr val="lt1"/>
+          </a:fontRef>
+        </p:style>
+        <p:txBody>
+          <a:bodyPr rtlCol="0" anchor="ctr" wrap="square"/>
+          <a:lstStyle/>
+          <a:p>
+            <a:pPr algn="ctr"/>
+            <a:r>
+              <a:rPr sz="1400">
+                <a:solidFill>
+                  <a:srgbClr val="5B6D82"/>
+                </a:solidFill>
+                <a:latin typeface="Microsoft YaHei"/>
+              </a:rPr>
+              <a:t>细绳修正：离焦图差 → 特征差</a:t>
+            </a:r>
+          </a:p>
+          <a:p>
+            <a:pPr algn="ctr"/>
+            <a:r>
+              <a:rPr sz="1400">
+                <a:solidFill>
+                  <a:srgbClr val="5B6D82"/>
+                </a:solidFill>
+                <a:latin typeface="Microsoft YaHei"/>
+              </a:rPr>
+              <a:t>（B33，待实验结果）</a:t>
+            </a:r>
+          </a:p>
+        </p:txBody>
+      </p:sp>
+      <p:sp>
+        <p:nvSpPr>
+          <p:cNvPr id="5" name="Rectangle 4"/>
+          <p:cNvSpPr/>
+          <p:nvPr/>
+        </p:nvSpPr>
+        <p:spPr>
+          <a:xfrm>
+            <a:off x="6675120" y="3337560"/>
+            <a:ext cx="4754880" cy="1965960"/>
+          </a:xfrm>
+          <a:prstGeom prst="rect">
+            <a:avLst/>
+          </a:prstGeom>
+          <a:solidFill>
+            <a:srgbClr val="F5F7FA"/>
+          </a:solidFill>
+          <a:ln>
+            <a:solidFill>
+              <a:srgbClr val="9FB3C8"/>
+            </a:solidFill>
+            <a:prstDash val="dash"/>
+          </a:ln>
+        </p:spPr>
+        <p:style>
+          <a:lnRef idx="1">
+            <a:schemeClr val="accent1"/>
+          </a:lnRef>
+          <a:fillRef idx="3">
+            <a:schemeClr val="accent1"/>
+          </a:fillRef>
+          <a:effectRef idx="2">
+            <a:schemeClr val="accent1"/>
+          </a:effectRef>
+          <a:fontRef idx="minor">
+            <a:schemeClr val="lt1"/>
+          </a:fontRef>
+        </p:style>
+        <p:txBody>
+          <a:bodyPr rtlCol="0" anchor="ctr" wrap="square"/>
+          <a:lstStyle/>
+          <a:p>
+            <a:pPr algn="ctr"/>
+            <a:r>
+              <a:rPr sz="1400">
+                <a:solidFill>
+                  <a:srgbClr val="5B6D82"/>
+                </a:solidFill>
+                <a:latin typeface="Microsoft YaHei"/>
+              </a:rPr>
+              <a:t>鸭头修正：离焦图差 → 特征差</a:t>
+            </a:r>
+          </a:p>
+          <a:p>
+            <a:pPr algn="ctr"/>
+            <a:r>
+              <a:rPr sz="1400">
+                <a:solidFill>
+                  <a:srgbClr val="5B6D82"/>
+                </a:solidFill>
+                <a:latin typeface="Microsoft YaHei"/>
+              </a:rPr>
+              <a:t>（B36，待实验结果）</a:t>
+            </a:r>
+          </a:p>
+        </p:txBody>
+      </p:sp>
+      <p:sp>
+        <p:nvSpPr>
+          <p:cNvPr id="6" name="Rectangle 5"/>
+          <p:cNvSpPr/>
+          <p:nvPr/>
+        </p:nvSpPr>
+        <p:spPr>
+          <a:xfrm>
+            <a:off x="777240" y="5486400"/>
+            <a:ext cx="10652760" cy="384048"/>
+          </a:xfrm>
+          <a:prstGeom prst="rect">
+            <a:avLst/>
+          </a:prstGeom>
+          <a:solidFill>
+            <a:srgbClr val="F5F7FA"/>
+          </a:solidFill>
+          <a:ln>
+            <a:solidFill>
+              <a:srgbClr val="9FB3C8"/>
+            </a:solidFill>
+            <a:prstDash val="dash"/>
+          </a:ln>
+        </p:spPr>
+        <p:style>
+          <a:lnRef idx="1">
+            <a:schemeClr val="accent1"/>
+          </a:lnRef>
+          <a:fillRef idx="3">
+            <a:schemeClr val="accent1"/>
+          </a:fillRef>
+          <a:effectRef idx="2">
+            <a:schemeClr val="accent1"/>
+          </a:effectRef>
+          <a:fontRef idx="minor">
+            <a:schemeClr val="lt1"/>
+          </a:fontRef>
+        </p:style>
+        <p:txBody>
+          <a:bodyPr rtlCol="0" anchor="ctr" wrap="square"/>
+          <a:lstStyle/>
+          <a:p>
+            <a:pPr algn="ctr"/>
+            <a:r>
+              <a:rPr sz="1400">
+                <a:solidFill>
+                  <a:srgbClr val="5B6D82"/>
+                </a:solidFill>
+                <a:latin typeface="Microsoft YaHei"/>
+              </a:rPr>
+              <a:t>一句结论（待实验结果）</a:t>
+            </a:r>
+          </a:p>
+        </p:txBody>
+      </p:sp>
+    </p:spTree>
+  </p:cSld>
+  <p:clrMapOvr>
+    <a:masterClrMapping/>
+  </p:clrMapOvr>
+</p:sld>
+</file>
+
+<file path=ppt/slides/slide5.xml><?xml version="1.0" encoding="utf-8"?>
+<p:sld xmlns:a="http://schemas.openxmlformats.org/drawingml/2006/main" xmlns:p="http://schemas.openxmlformats.org/presentationml/2006/main" xmlns:r="http://schemas.openxmlformats.org/officeDocument/2006/relationships">
+  <p:cSld>
+    <p:spTree>
+      <p:nvGrpSpPr>
+        <p:cNvPr id="1" name=""/>
+        <p:cNvGrpSpPr/>
+        <p:nvPr/>
+      </p:nvGrpSpPr>
+      <p:grpSpPr/>
+      <p:sp>
+        <p:nvSpPr>
+          <p:cNvPr id="2" name="TextBox 1"/>
+          <p:cNvSpPr txBox="1"/>
+          <p:nvPr/>
+        </p:nvSpPr>
+        <p:spPr>
+          <a:xfrm>
+            <a:off x="667512" y="283464"/>
+            <a:ext cx="10058400" cy="438912"/>
+          </a:xfrm>
+          <a:prstGeom prst="rect">
+            <a:avLst/>
+          </a:prstGeom>
+          <a:noFill/>
+        </p:spPr>
+        <p:txBody>
+          <a:bodyPr wrap="square">
+            <a:spAutoFit/>
+          </a:bodyPr>
+          <a:lstStyle/>
+          <a:p>
+            <a:pPr algn="l"/>
+            <a:r>
+              <a:rPr sz="2850" b="1">
+                <a:solidFill>
+                  <a:srgbClr val="0D569A"/>
+                </a:solidFill>
+                <a:latin typeface="Microsoft YaHei"/>
+              </a:rPr>
+              <a:t>鸭头全 25 帧局部修正</a:t>
+            </a:r>
+          </a:p>
+        </p:txBody>
+      </p:sp>
+      <p:sp>
+        <p:nvSpPr>
+          <p:cNvPr id="3" name="TextBox 2"/>
+          <p:cNvSpPr txBox="1"/>
+          <p:nvPr/>
+        </p:nvSpPr>
+        <p:spPr>
+          <a:xfrm>
+            <a:off x="1691640" y="1051560"/>
+            <a:ext cx="1783080" cy="274320"/>
+          </a:xfrm>
+          <a:prstGeom prst="rect">
+            <a:avLst/>
+          </a:prstGeom>
+          <a:noFill/>
+        </p:spPr>
+        <p:txBody>
+          <a:bodyPr wrap="square">
+            <a:spAutoFit/>
+          </a:bodyPr>
+          <a:lstStyle/>
+          <a:p>
+            <a:pPr algn="ctr"/>
+            <a:r>
+              <a:rPr sz="1400" b="1">
+                <a:solidFill>
+                  <a:srgbClr val="0D569A"/>
+                </a:solidFill>
+                <a:latin typeface="Microsoft YaHei"/>
+              </a:rPr>
+              <a:t>第 0 帧</a:t>
+            </a:r>
+          </a:p>
+        </p:txBody>
+      </p:sp>
+      <p:sp>
+        <p:nvSpPr>
+          <p:cNvPr id="4" name="TextBox 3"/>
+          <p:cNvSpPr txBox="1"/>
+          <p:nvPr/>
+        </p:nvSpPr>
+        <p:spPr>
+          <a:xfrm>
+            <a:off x="3566160" y="1051560"/>
+            <a:ext cx="1783080" cy="274320"/>
+          </a:xfrm>
+          <a:prstGeom prst="rect">
+            <a:avLst/>
+          </a:prstGeom>
+          <a:noFill/>
+        </p:spPr>
+        <p:txBody>
+          <a:bodyPr wrap="square">
+            <a:spAutoFit/>
+          </a:bodyPr>
+          <a:lstStyle/>
+          <a:p>
+            <a:pPr algn="ctr"/>
+            <a:r>
+              <a:rPr sz="1400" b="1">
+                <a:solidFill>
+                  <a:srgbClr val="0D569A"/>
+                </a:solidFill>
+                <a:latin typeface="Microsoft YaHei"/>
+              </a:rPr>
+              <a:t>第 8 帧</a:t>
+            </a:r>
+          </a:p>
+        </p:txBody>
+      </p:sp>
+      <p:sp>
+        <p:nvSpPr>
+          <p:cNvPr id="5" name="TextBox 4"/>
+          <p:cNvSpPr txBox="1"/>
+          <p:nvPr/>
+        </p:nvSpPr>
+        <p:spPr>
+          <a:xfrm>
+            <a:off x="5440679" y="1051560"/>
+            <a:ext cx="1783080" cy="274320"/>
+          </a:xfrm>
+          <a:prstGeom prst="rect">
+            <a:avLst/>
+          </a:prstGeom>
+          <a:noFill/>
+        </p:spPr>
+        <p:txBody>
+          <a:bodyPr wrap="square">
+            <a:spAutoFit/>
+          </a:bodyPr>
+          <a:lstStyle/>
+          <a:p>
+            <a:pPr algn="ctr"/>
+            <a:r>
+              <a:rPr sz="1400" b="1">
+                <a:solidFill>
+                  <a:srgbClr val="0D569A"/>
+                </a:solidFill>
+                <a:latin typeface="Microsoft YaHei"/>
+              </a:rPr>
+              <a:t>第 16 帧</a:t>
+            </a:r>
+          </a:p>
+        </p:txBody>
+      </p:sp>
+      <p:sp>
+        <p:nvSpPr>
+          <p:cNvPr id="6" name="TextBox 5"/>
+          <p:cNvSpPr txBox="1"/>
+          <p:nvPr/>
+        </p:nvSpPr>
+        <p:spPr>
+          <a:xfrm>
+            <a:off x="7315200" y="1051560"/>
+            <a:ext cx="1783080" cy="274320"/>
+          </a:xfrm>
+          <a:prstGeom prst="rect">
+            <a:avLst/>
+          </a:prstGeom>
+          <a:noFill/>
+        </p:spPr>
+        <p:txBody>
+          <a:bodyPr wrap="square">
+            <a:spAutoFit/>
+          </a:bodyPr>
+          <a:lstStyle/>
+          <a:p>
+            <a:pPr algn="ctr"/>
+            <a:r>
+              <a:rPr sz="1400" b="1">
+                <a:solidFill>
+                  <a:srgbClr val="0D569A"/>
+                </a:solidFill>
+                <a:latin typeface="Microsoft YaHei"/>
+              </a:rPr>
+              <a:t>第 24 帧</a:t>
+            </a:r>
+          </a:p>
+        </p:txBody>
+      </p:sp>
+      <p:sp>
+        <p:nvSpPr>
+          <p:cNvPr id="7" name="TextBox 6"/>
+          <p:cNvSpPr txBox="1"/>
+          <p:nvPr/>
+        </p:nvSpPr>
+        <p:spPr>
+          <a:xfrm>
+            <a:off x="640080" y="1755648"/>
+            <a:ext cx="1005840" cy="329184"/>
+          </a:xfrm>
+          <a:prstGeom prst="rect">
+            <a:avLst/>
+          </a:prstGeom>
+          <a:noFill/>
+        </p:spPr>
+        <p:txBody>
+          <a:bodyPr wrap="square">
+            <a:spAutoFit/>
+          </a:bodyPr>
+          <a:lstStyle/>
+          <a:p>
+            <a:pPr algn="r"/>
+            <a:r>
+              <a:rPr sz="1500" b="1">
+                <a:solidFill>
+                  <a:srgbClr val="0D569A"/>
+                </a:solidFill>
+                <a:latin typeface="Microsoft YaHei"/>
+              </a:rPr>
+              <a:t>原图</a:t>
+            </a:r>
+          </a:p>
+        </p:txBody>
+      </p:sp>
+      <p:sp>
+        <p:nvSpPr>
+          <p:cNvPr id="8" name="Rectangle 7"/>
+          <p:cNvSpPr/>
+          <p:nvPr/>
+        </p:nvSpPr>
+        <p:spPr>
+          <a:xfrm>
+            <a:off x="1691640" y="1371600"/>
+            <a:ext cx="1783080" cy="1097280"/>
+          </a:xfrm>
+          <a:prstGeom prst="rect">
+            <a:avLst/>
+          </a:prstGeom>
+          <a:solidFill>
+            <a:srgbClr val="F5F7FA"/>
+          </a:solidFill>
+          <a:ln>
+            <a:solidFill>
+              <a:srgbClr val="9FB3C8"/>
+            </a:solidFill>
+            <a:prstDash val="dash"/>
+          </a:ln>
+        </p:spPr>
+        <p:style>
+          <a:lnRef idx="1">
+            <a:schemeClr val="accent1"/>
+          </a:lnRef>
+          <a:fillRef idx="3">
+            <a:schemeClr val="accent1"/>
+          </a:fillRef>
+          <a:effectRef idx="2">
+            <a:schemeClr val="accent1"/>
+          </a:effectRef>
+          <a:fontRef idx="minor">
+            <a:schemeClr val="lt1"/>
+          </a:fontRef>
+        </p:style>
+        <p:txBody>
+          <a:bodyPr rtlCol="0" anchor="ctr" wrap="square"/>
+          <a:lstStyle/>
+          <a:p>
+            <a:pPr algn="ctr"/>
+            <a:r>
+              <a:rPr sz="1400">
+                <a:solidFill>
+                  <a:srgbClr val="5B6D82"/>
+                </a:solidFill>
+                <a:latin typeface="Microsoft YaHei"/>
+              </a:rPr>
+              <a:t>待补图</a:t>
+            </a:r>
+          </a:p>
+        </p:txBody>
+      </p:sp>
+      <p:sp>
+        <p:nvSpPr>
+          <p:cNvPr id="9" name="Rectangle 8"/>
+          <p:cNvSpPr/>
+          <p:nvPr/>
+        </p:nvSpPr>
+        <p:spPr>
+          <a:xfrm>
+            <a:off x="3566160" y="1371600"/>
+            <a:ext cx="1783080" cy="1097280"/>
+          </a:xfrm>
+          <a:prstGeom prst="rect">
+            <a:avLst/>
+          </a:prstGeom>
+          <a:solidFill>
+            <a:srgbClr val="F5F7FA"/>
+          </a:solidFill>
+          <a:ln>
+            <a:solidFill>
+              <a:srgbClr val="9FB3C8"/>
+            </a:solidFill>
+            <a:prstDash val="dash"/>
+          </a:ln>
+        </p:spPr>
+        <p:style>
+          <a:lnRef idx="1">
+            <a:schemeClr val="accent1"/>
+          </a:lnRef>
+          <a:fillRef idx="3">
+            <a:schemeClr val="accent1"/>
+          </a:fillRef>
+          <a:effectRef idx="2">
+            <a:schemeClr val="accent1"/>
+          </a:effectRef>
+          <a:fontRef idx="minor">
+            <a:schemeClr val="lt1"/>
+          </a:fontRef>
+        </p:style>
+        <p:txBody>
+          <a:bodyPr rtlCol="0" anchor="ctr" wrap="square"/>
+          <a:lstStyle/>
+          <a:p>
+            <a:pPr algn="ctr"/>
+            <a:r>
+              <a:rPr sz="1400">
+                <a:solidFill>
+                  <a:srgbClr val="5B6D82"/>
+                </a:solidFill>
+                <a:latin typeface="Microsoft YaHei"/>
+              </a:rPr>
+              <a:t>待补图</a:t>
+            </a:r>
+          </a:p>
+        </p:txBody>
+      </p:sp>
+      <p:sp>
+        <p:nvSpPr>
+          <p:cNvPr id="10" name="Rectangle 9"/>
+          <p:cNvSpPr/>
+          <p:nvPr/>
+        </p:nvSpPr>
+        <p:spPr>
+          <a:xfrm>
+            <a:off x="5440679" y="1371600"/>
+            <a:ext cx="1783080" cy="1097280"/>
+          </a:xfrm>
+          <a:prstGeom prst="rect">
+            <a:avLst/>
+          </a:prstGeom>
+          <a:solidFill>
+            <a:srgbClr val="F5F7FA"/>
+          </a:solidFill>
+          <a:ln>
+            <a:solidFill>
+              <a:srgbClr val="9FB3C8"/>
+            </a:solidFill>
+            <a:prstDash val="dash"/>
+          </a:ln>
+        </p:spPr>
+        <p:style>
+          <a:lnRef idx="1">
+            <a:schemeClr val="accent1"/>
+          </a:lnRef>
+          <a:fillRef idx="3">
+            <a:schemeClr val="accent1"/>
+          </a:fillRef>
+          <a:effectRef idx="2">
+            <a:schemeClr val="accent1"/>
+          </a:effectRef>
+          <a:fontRef idx="minor">
+            <a:schemeClr val="lt1"/>
+          </a:fontRef>
+        </p:style>
+        <p:txBody>
+          <a:bodyPr rtlCol="0" anchor="ctr" wrap="square"/>
+          <a:lstStyle/>
+          <a:p>
+            <a:pPr algn="ctr"/>
+            <a:r>
+              <a:rPr sz="1400">
+                <a:solidFill>
+                  <a:srgbClr val="5B6D82"/>
+                </a:solidFill>
+                <a:latin typeface="Microsoft YaHei"/>
+              </a:rPr>
+              <a:t>待补图</a:t>
+            </a:r>
+          </a:p>
+        </p:txBody>
+      </p:sp>
+      <p:sp>
+        <p:nvSpPr>
+          <p:cNvPr id="11" name="Rectangle 10"/>
+          <p:cNvSpPr/>
+          <p:nvPr/>
+        </p:nvSpPr>
+        <p:spPr>
+          <a:xfrm>
+            <a:off x="7315200" y="1371600"/>
+            <a:ext cx="1783080" cy="1097280"/>
+          </a:xfrm>
+          <a:prstGeom prst="rect">
+            <a:avLst/>
+          </a:prstGeom>
+          <a:solidFill>
+            <a:srgbClr val="F5F7FA"/>
+          </a:solidFill>
+          <a:ln>
+            <a:solidFill>
+              <a:srgbClr val="9FB3C8"/>
+            </a:solidFill>
+            <a:prstDash val="dash"/>
+          </a:ln>
+        </p:spPr>
+        <p:style>
+          <a:lnRef idx="1">
+            <a:schemeClr val="accent1"/>
+          </a:lnRef>
+          <a:fillRef idx="3">
+            <a:schemeClr val="accent1"/>
+          </a:fillRef>
+          <a:effectRef idx="2">
+            <a:schemeClr val="accent1"/>
+          </a:effectRef>
+          <a:fontRef idx="minor">
+            <a:schemeClr val="lt1"/>
+          </a:fontRef>
+        </p:style>
+        <p:txBody>
+          <a:bodyPr rtlCol="0" anchor="ctr" wrap="square"/>
+          <a:lstStyle/>
+          <a:p>
+            <a:pPr algn="ctr"/>
+            <a:r>
+              <a:rPr sz="1400">
+                <a:solidFill>
+                  <a:srgbClr val="5B6D82"/>
+                </a:solidFill>
+                <a:latin typeface="Microsoft YaHei"/>
+              </a:rPr>
+              <a:t>待补图</a:t>
+            </a:r>
+          </a:p>
+        </p:txBody>
+      </p:sp>
+      <p:sp>
+        <p:nvSpPr>
+          <p:cNvPr id="12" name="TextBox 11"/>
+          <p:cNvSpPr txBox="1"/>
+          <p:nvPr/>
+        </p:nvSpPr>
+        <p:spPr>
+          <a:xfrm>
+            <a:off x="640080" y="2944368"/>
+            <a:ext cx="1005840" cy="329184"/>
+          </a:xfrm>
+          <a:prstGeom prst="rect">
+            <a:avLst/>
+          </a:prstGeom>
+          <a:noFill/>
+        </p:spPr>
+        <p:txBody>
+          <a:bodyPr wrap="square">
+            <a:spAutoFit/>
+          </a:bodyPr>
+          <a:lstStyle/>
+          <a:p>
+            <a:pPr algn="r"/>
+            <a:r>
+              <a:rPr sz="1500" b="1">
+                <a:solidFill>
+                  <a:srgbClr val="0D569A"/>
+                </a:solidFill>
+                <a:latin typeface="Microsoft YaHei"/>
+              </a:rPr>
+              <a:t>原版</a:t>
+            </a:r>
+          </a:p>
+        </p:txBody>
+      </p:sp>
+      <p:sp>
+        <p:nvSpPr>
+          <p:cNvPr id="13" name="Rectangle 12"/>
+          <p:cNvSpPr/>
+          <p:nvPr/>
+        </p:nvSpPr>
+        <p:spPr>
+          <a:xfrm>
+            <a:off x="1691640" y="2560320"/>
+            <a:ext cx="1783080" cy="1097280"/>
+          </a:xfrm>
+          <a:prstGeom prst="rect">
+            <a:avLst/>
+          </a:prstGeom>
+          <a:solidFill>
+            <a:srgbClr val="F5F7FA"/>
+          </a:solidFill>
+          <a:ln>
+            <a:solidFill>
+              <a:srgbClr val="9FB3C8"/>
+            </a:solidFill>
+            <a:prstDash val="dash"/>
+          </a:ln>
+        </p:spPr>
+        <p:style>
+          <a:lnRef idx="1">
+            <a:schemeClr val="accent1"/>
+          </a:lnRef>
+          <a:fillRef idx="3">
+            <a:schemeClr val="accent1"/>
+          </a:fillRef>
+          <a:effectRef idx="2">
+            <a:schemeClr val="accent1"/>
+          </a:effectRef>
+          <a:fontRef idx="minor">
+            <a:schemeClr val="lt1"/>
+          </a:fontRef>
+        </p:style>
+        <p:txBody>
+          <a:bodyPr rtlCol="0" anchor="ctr" wrap="square"/>
+          <a:lstStyle/>
+          <a:p>
+            <a:pPr algn="ctr"/>
+            <a:r>
+              <a:rPr sz="1400">
+                <a:solidFill>
+                  <a:srgbClr val="5B6D82"/>
+                </a:solidFill>
+                <a:latin typeface="Microsoft YaHei"/>
+              </a:rPr>
+              <a:t>待补图</a:t>
+            </a:r>
+          </a:p>
+        </p:txBody>
+      </p:sp>
+      <p:sp>
+        <p:nvSpPr>
+          <p:cNvPr id="14" name="Rectangle 13"/>
+          <p:cNvSpPr/>
+          <p:nvPr/>
+        </p:nvSpPr>
+        <p:spPr>
+          <a:xfrm>
+            <a:off x="3566160" y="2560320"/>
+            <a:ext cx="1783080" cy="1097280"/>
+          </a:xfrm>
+          <a:prstGeom prst="rect">
+            <a:avLst/>
+          </a:prstGeom>
+          <a:solidFill>
+            <a:srgbClr val="F5F7FA"/>
+          </a:solidFill>
+          <a:ln>
+            <a:solidFill>
+              <a:srgbClr val="9FB3C8"/>
+            </a:solidFill>
+            <a:prstDash val="dash"/>
+          </a:ln>
+        </p:spPr>
+        <p:style>
+          <a:lnRef idx="1">
+            <a:schemeClr val="accent1"/>
+          </a:lnRef>
+          <a:fillRef idx="3">
+            <a:schemeClr val="accent1"/>
+          </a:fillRef>
+          <a:effectRef idx="2">
+            <a:schemeClr val="accent1"/>
+          </a:effectRef>
+          <a:fontRef idx="minor">
+            <a:schemeClr val="lt1"/>
+          </a:fontRef>
+        </p:style>
+        <p:txBody>
+          <a:bodyPr rtlCol="0" anchor="ctr" wrap="square"/>
+          <a:lstStyle/>
+          <a:p>
+            <a:pPr algn="ctr"/>
+            <a:r>
+              <a:rPr sz="1400">
+                <a:solidFill>
+                  <a:srgbClr val="5B6D82"/>
+                </a:solidFill>
+                <a:latin typeface="Microsoft YaHei"/>
+              </a:rPr>
+              <a:t>待补图</a:t>
+            </a:r>
+          </a:p>
+        </p:txBody>
+      </p:sp>
+      <p:sp>
+        <p:nvSpPr>
+          <p:cNvPr id="15" name="Rectangle 14"/>
+          <p:cNvSpPr/>
+          <p:nvPr/>
+        </p:nvSpPr>
+        <p:spPr>
+          <a:xfrm>
+            <a:off x="5440679" y="2560320"/>
+            <a:ext cx="1783080" cy="1097280"/>
+          </a:xfrm>
+          <a:prstGeom prst="rect">
+            <a:avLst/>
+          </a:prstGeom>
+          <a:solidFill>
+            <a:srgbClr val="F5F7FA"/>
+          </a:solidFill>
+          <a:ln>
+            <a:solidFill>
+              <a:srgbClr val="9FB3C8"/>
+            </a:solidFill>
+            <a:prstDash val="dash"/>
+          </a:ln>
+        </p:spPr>
+        <p:style>
+          <a:lnRef idx="1">
+            <a:schemeClr val="accent1"/>
+          </a:lnRef>
+          <a:fillRef idx="3">
+            <a:schemeClr val="accent1"/>
+          </a:fillRef>
+          <a:effectRef idx="2">
+            <a:schemeClr val="accent1"/>
+          </a:effectRef>
+          <a:fontRef idx="minor">
+            <a:schemeClr val="lt1"/>
+          </a:fontRef>
+        </p:style>
+        <p:txBody>
+          <a:bodyPr rtlCol="0" anchor="ctr" wrap="square"/>
+          <a:lstStyle/>
+          <a:p>
+            <a:pPr algn="ctr"/>
+            <a:r>
+              <a:rPr sz="1400">
+                <a:solidFill>
+                  <a:srgbClr val="5B6D82"/>
+                </a:solidFill>
+                <a:latin typeface="Microsoft YaHei"/>
+              </a:rPr>
+              <a:t>待补图</a:t>
+            </a:r>
+          </a:p>
+        </p:txBody>
+      </p:sp>
+      <p:sp>
+        <p:nvSpPr>
+          <p:cNvPr id="16" name="Rectangle 15"/>
+          <p:cNvSpPr/>
+          <p:nvPr/>
+        </p:nvSpPr>
+        <p:spPr>
+          <a:xfrm>
+            <a:off x="7315200" y="2560320"/>
+            <a:ext cx="1783080" cy="1097280"/>
+          </a:xfrm>
+          <a:prstGeom prst="rect">
+            <a:avLst/>
+          </a:prstGeom>
+          <a:solidFill>
+            <a:srgbClr val="F5F7FA"/>
+          </a:solidFill>
+          <a:ln>
+            <a:solidFill>
+              <a:srgbClr val="9FB3C8"/>
+            </a:solidFill>
+            <a:prstDash val="dash"/>
+          </a:ln>
+        </p:spPr>
+        <p:style>
+          <a:lnRef idx="1">
+            <a:schemeClr val="accent1"/>
+          </a:lnRef>
+          <a:fillRef idx="3">
+            <a:schemeClr val="accent1"/>
+          </a:fillRef>
+          <a:effectRef idx="2">
+            <a:schemeClr val="accent1"/>
+          </a:effectRef>
+          <a:fontRef idx="minor">
+            <a:schemeClr val="lt1"/>
+          </a:fontRef>
+        </p:style>
+        <p:txBody>
+          <a:bodyPr rtlCol="0" anchor="ctr" wrap="square"/>
+          <a:lstStyle/>
+          <a:p>
+            <a:pPr algn="ctr"/>
+            <a:r>
+              <a:rPr sz="1400">
+                <a:solidFill>
+                  <a:srgbClr val="5B6D82"/>
+                </a:solidFill>
+                <a:latin typeface="Microsoft YaHei"/>
+              </a:rPr>
+              <a:t>待补图</a:t>
+            </a:r>
+          </a:p>
+        </p:txBody>
+      </p:sp>
+      <p:sp>
+        <p:nvSpPr>
+          <p:cNvPr id="17" name="TextBox 16"/>
+          <p:cNvSpPr txBox="1"/>
+          <p:nvPr/>
+        </p:nvSpPr>
+        <p:spPr>
+          <a:xfrm>
+            <a:off x="640080" y="4133087"/>
+            <a:ext cx="1005840" cy="329184"/>
+          </a:xfrm>
+          <a:prstGeom prst="rect">
+            <a:avLst/>
+          </a:prstGeom>
+          <a:noFill/>
+        </p:spPr>
+        <p:txBody>
+          <a:bodyPr wrap="square">
+            <a:spAutoFit/>
+          </a:bodyPr>
+          <a:lstStyle/>
+          <a:p>
+            <a:pPr algn="r"/>
+            <a:r>
+              <a:rPr sz="1500" b="1">
+                <a:solidFill>
+                  <a:srgbClr val="0D569A"/>
+                </a:solidFill>
+                <a:latin typeface="Microsoft YaHei"/>
+              </a:rPr>
+              <a:t>全帧修正</a:t>
+            </a:r>
+          </a:p>
+        </p:txBody>
+      </p:sp>
+      <p:sp>
+        <p:nvSpPr>
+          <p:cNvPr id="18" name="Rectangle 17"/>
+          <p:cNvSpPr/>
+          <p:nvPr/>
+        </p:nvSpPr>
+        <p:spPr>
+          <a:xfrm>
+            <a:off x="1691640" y="3749039"/>
+            <a:ext cx="1783080" cy="1097280"/>
+          </a:xfrm>
+          <a:prstGeom prst="rect">
+            <a:avLst/>
+          </a:prstGeom>
+          <a:solidFill>
+            <a:srgbClr val="F5F7FA"/>
+          </a:solidFill>
+          <a:ln>
+            <a:solidFill>
+              <a:srgbClr val="9FB3C8"/>
+            </a:solidFill>
+            <a:prstDash val="dash"/>
+          </a:ln>
+        </p:spPr>
+        <p:style>
+          <a:lnRef idx="1">
+            <a:schemeClr val="accent1"/>
+          </a:lnRef>
+          <a:fillRef idx="3">
+            <a:schemeClr val="accent1"/>
+          </a:fillRef>
+          <a:effectRef idx="2">
+            <a:schemeClr val="accent1"/>
+          </a:effectRef>
+          <a:fontRef idx="minor">
+            <a:schemeClr val="lt1"/>
+          </a:fontRef>
+        </p:style>
+        <p:txBody>
+          <a:bodyPr rtlCol="0" anchor="ctr" wrap="square"/>
+          <a:lstStyle/>
+          <a:p>
+            <a:pPr algn="ctr"/>
+            <a:r>
+              <a:rPr sz="1400">
+                <a:solidFill>
+                  <a:srgbClr val="5B6D82"/>
+                </a:solidFill>
+                <a:latin typeface="Microsoft YaHei"/>
+              </a:rPr>
+              <a:t>待补图</a:t>
+            </a:r>
+          </a:p>
+        </p:txBody>
+      </p:sp>
+      <p:sp>
+        <p:nvSpPr>
+          <p:cNvPr id="19" name="Rectangle 18"/>
+          <p:cNvSpPr/>
+          <p:nvPr/>
+        </p:nvSpPr>
+        <p:spPr>
+          <a:xfrm>
+            <a:off x="3566160" y="3749039"/>
+            <a:ext cx="1783080" cy="1097280"/>
+          </a:xfrm>
+          <a:prstGeom prst="rect">
+            <a:avLst/>
+          </a:prstGeom>
+          <a:solidFill>
+            <a:srgbClr val="F5F7FA"/>
+          </a:solidFill>
+          <a:ln>
+            <a:solidFill>
+              <a:srgbClr val="9FB3C8"/>
+            </a:solidFill>
+            <a:prstDash val="dash"/>
+          </a:ln>
+        </p:spPr>
+        <p:style>
+          <a:lnRef idx="1">
+            <a:schemeClr val="accent1"/>
+          </a:lnRef>
+          <a:fillRef idx="3">
+            <a:schemeClr val="accent1"/>
+          </a:fillRef>
+          <a:effectRef idx="2">
+            <a:schemeClr val="accent1"/>
+          </a:effectRef>
+          <a:fontRef idx="minor">
+            <a:schemeClr val="lt1"/>
+          </a:fontRef>
+        </p:style>
+        <p:txBody>
+          <a:bodyPr rtlCol="0" anchor="ctr" wrap="square"/>
+          <a:lstStyle/>
+          <a:p>
+            <a:pPr algn="ctr"/>
+            <a:r>
+              <a:rPr sz="1400">
+                <a:solidFill>
+                  <a:srgbClr val="5B6D82"/>
+                </a:solidFill>
+                <a:latin typeface="Microsoft YaHei"/>
+              </a:rPr>
+              <a:t>待补图</a:t>
+            </a:r>
+          </a:p>
+        </p:txBody>
+      </p:sp>
+      <p:sp>
+        <p:nvSpPr>
+          <p:cNvPr id="20" name="Rectangle 19"/>
+          <p:cNvSpPr/>
+          <p:nvPr/>
+        </p:nvSpPr>
+        <p:spPr>
+          <a:xfrm>
+            <a:off x="5440679" y="3749039"/>
+            <a:ext cx="1783080" cy="1097280"/>
+          </a:xfrm>
+          <a:prstGeom prst="rect">
+            <a:avLst/>
+          </a:prstGeom>
+          <a:solidFill>
+            <a:srgbClr val="F5F7FA"/>
+          </a:solidFill>
+          <a:ln>
+            <a:solidFill>
+              <a:srgbClr val="9FB3C8"/>
+            </a:solidFill>
+            <a:prstDash val="dash"/>
+          </a:ln>
+        </p:spPr>
+        <p:style>
+          <a:lnRef idx="1">
+            <a:schemeClr val="accent1"/>
+          </a:lnRef>
+          <a:fillRef idx="3">
+            <a:schemeClr val="accent1"/>
+          </a:fillRef>
+          <a:effectRef idx="2">
+            <a:schemeClr val="accent1"/>
+          </a:effectRef>
+          <a:fontRef idx="minor">
+            <a:schemeClr val="lt1"/>
+          </a:fontRef>
+        </p:style>
+        <p:txBody>
+          <a:bodyPr rtlCol="0" anchor="ctr" wrap="square"/>
+          <a:lstStyle/>
+          <a:p>
+            <a:pPr algn="ctr"/>
+            <a:r>
+              <a:rPr sz="1400">
+                <a:solidFill>
+                  <a:srgbClr val="5B6D82"/>
+                </a:solidFill>
+                <a:latin typeface="Microsoft YaHei"/>
+              </a:rPr>
+              <a:t>待补图</a:t>
+            </a:r>
+          </a:p>
+        </p:txBody>
+      </p:sp>
+      <p:sp>
+        <p:nvSpPr>
+          <p:cNvPr id="21" name="Rectangle 20"/>
+          <p:cNvSpPr/>
+          <p:nvPr/>
+        </p:nvSpPr>
+        <p:spPr>
+          <a:xfrm>
+            <a:off x="7315200" y="3749039"/>
+            <a:ext cx="1783080" cy="1097280"/>
+          </a:xfrm>
+          <a:prstGeom prst="rect">
+            <a:avLst/>
+          </a:prstGeom>
+          <a:solidFill>
+            <a:srgbClr val="F5F7FA"/>
+          </a:solidFill>
+          <a:ln>
+            <a:solidFill>
+              <a:srgbClr val="9FB3C8"/>
+            </a:solidFill>
+            <a:prstDash val="dash"/>
+          </a:ln>
+        </p:spPr>
+        <p:style>
+          <a:lnRef idx="1">
+            <a:schemeClr val="accent1"/>
+          </a:lnRef>
+          <a:fillRef idx="3">
+            <a:schemeClr val="accent1"/>
+          </a:fillRef>
+          <a:effectRef idx="2">
+            <a:schemeClr val="accent1"/>
+          </a:effectRef>
+          <a:fontRef idx="minor">
+            <a:schemeClr val="lt1"/>
+          </a:fontRef>
+        </p:style>
+        <p:txBody>
+          <a:bodyPr rtlCol="0" anchor="ctr" wrap="square"/>
+          <a:lstStyle/>
+          <a:p>
+            <a:pPr algn="ctr"/>
+            <a:r>
+              <a:rPr sz="1400">
+                <a:solidFill>
+                  <a:srgbClr val="5B6D82"/>
+                </a:solidFill>
+                <a:latin typeface="Microsoft YaHei"/>
+              </a:rPr>
+              <a:t>待补图</a:t>
+            </a:r>
+          </a:p>
+        </p:txBody>
+      </p:sp>
+      <p:sp>
+        <p:nvSpPr>
+          <p:cNvPr id="22" name="Rectangle 21"/>
+          <p:cNvSpPr/>
+          <p:nvPr/>
+        </p:nvSpPr>
+        <p:spPr>
+          <a:xfrm>
+            <a:off x="9372600" y="1371600"/>
+            <a:ext cx="2057400" cy="3474720"/>
+          </a:xfrm>
+          <a:prstGeom prst="rect">
+            <a:avLst/>
+          </a:prstGeom>
+          <a:solidFill>
+            <a:srgbClr val="F5F7FA"/>
+          </a:solidFill>
+          <a:ln>
+            <a:solidFill>
+              <a:srgbClr val="9FB3C8"/>
+            </a:solidFill>
+            <a:prstDash val="dash"/>
+          </a:ln>
+        </p:spPr>
+        <p:style>
+          <a:lnRef idx="1">
+            <a:schemeClr val="accent1"/>
+          </a:lnRef>
+          <a:fillRef idx="3">
+            <a:schemeClr val="accent1"/>
+          </a:fillRef>
+          <a:effectRef idx="2">
+            <a:schemeClr val="accent1"/>
+          </a:effectRef>
+          <a:fontRef idx="minor">
+            <a:schemeClr val="lt1"/>
+          </a:fontRef>
+        </p:style>
+        <p:txBody>
+          <a:bodyPr rtlCol="0" anchor="ctr" wrap="square"/>
+          <a:lstStyle/>
+          <a:p>
+            <a:pPr algn="ctr"/>
+            <a:r>
+              <a:rPr sz="1400">
+                <a:solidFill>
+                  <a:srgbClr val="5B6D82"/>
+                </a:solidFill>
+                <a:latin typeface="Microsoft YaHei"/>
+              </a:rPr>
+              <a:t>指标小表</a:t>
+            </a:r>
+          </a:p>
+          <a:p>
+            <a:pPr algn="ctr"/>
+            <a:r>
+              <a:rPr sz="1400">
+                <a:solidFill>
+                  <a:srgbClr val="5B6D82"/>
+                </a:solidFill>
+                <a:latin typeface="Microsoft YaHei"/>
+              </a:rPr>
+              <a:t>头部清晰度</a:t>
+            </a:r>
+          </a:p>
+          <a:p>
+            <a:pPr algn="ctr"/>
+            <a:r>
+              <a:rPr sz="1400">
+                <a:solidFill>
+                  <a:srgbClr val="5B6D82"/>
+                </a:solidFill>
+                <a:latin typeface="Microsoft YaHei"/>
+              </a:rPr>
+              <a:t>旁效应</a:t>
+            </a:r>
+          </a:p>
+          <a:p>
+            <a:pPr algn="ctr"/>
+            <a:r>
+              <a:rPr sz="1400">
+                <a:solidFill>
+                  <a:srgbClr val="5B6D82"/>
+                </a:solidFill>
+                <a:latin typeface="Microsoft YaHei"/>
+              </a:rPr>
+              <a:t>时序</a:t>
+            </a:r>
+          </a:p>
+          <a:p>
+            <a:pPr algn="ctr"/>
+            <a:r>
+              <a:rPr sz="1400">
+                <a:solidFill>
+                  <a:srgbClr val="5B6D82"/>
+                </a:solidFill>
+                <a:latin typeface="Microsoft YaHei"/>
+              </a:rPr>
+              <a:t>（待实验结果）</a:t>
+            </a:r>
+          </a:p>
+        </p:txBody>
+      </p:sp>
+      <p:sp>
+        <p:nvSpPr>
+          <p:cNvPr id="23" name="Rectangle 22"/>
+          <p:cNvSpPr/>
+          <p:nvPr/>
+        </p:nvSpPr>
+        <p:spPr>
+          <a:xfrm>
+            <a:off x="777240" y="5486400"/>
+            <a:ext cx="10652760" cy="384048"/>
+          </a:xfrm>
+          <a:prstGeom prst="rect">
+            <a:avLst/>
+          </a:prstGeom>
+          <a:solidFill>
+            <a:srgbClr val="F5F7FA"/>
+          </a:solidFill>
+          <a:ln>
+            <a:solidFill>
+              <a:srgbClr val="9FB3C8"/>
+            </a:solidFill>
+            <a:prstDash val="dash"/>
+          </a:ln>
+        </p:spPr>
+        <p:style>
+          <a:lnRef idx="1">
+            <a:schemeClr val="accent1"/>
+          </a:lnRef>
+          <a:fillRef idx="3">
+            <a:schemeClr val="accent1"/>
+          </a:fillRef>
+          <a:effectRef idx="2">
+            <a:schemeClr val="accent1"/>
+          </a:effectRef>
+          <a:fontRef idx="minor">
+            <a:schemeClr val="lt1"/>
+          </a:fontRef>
+        </p:style>
+        <p:txBody>
+          <a:bodyPr rtlCol="0" anchor="ctr" wrap="square"/>
+          <a:lstStyle/>
+          <a:p>
+            <a:pPr algn="ctr"/>
+            <a:r>
+              <a:rPr sz="1400">
+                <a:solidFill>
+                  <a:srgbClr val="5B6D82"/>
+                </a:solidFill>
+                <a:latin typeface="Microsoft YaHei"/>
+              </a:rPr>
+              <a:t>一句结论（待实验结果）</a:t>
             </a:r>
           </a:p>
         </p:txBody>

</xml_diff>

<commit_message>
report: shorten ATB slide titles in 1023 deck
Titles now state each page's finding or question directly; speech headings match.

Co-Authored-By: Claude Opus 5.5 (1M context) <noreply@anthropic.com>
</commit_message>
<xml_diff>
--- a/汇报/2026-10-23_ATB进展与FlashReFocus/FlashReFocus_论文介绍_1023.pptx
+++ b/汇报/2026-10-23_ATB进展与FlashReFocus/FlashReFocus_论文介绍_1023.pptx
@@ -7823,7 +7823,7 @@
                 </a:solidFill>
                 <a:latin typeface="Microsoft YaHei"/>
               </a:rPr>
-              <a:t>ATB 条件核验：几何只经离焦图起作用</a:t>
+              <a:t>几何条件只经离焦图生效</a:t>
             </a:r>
           </a:p>
         </p:txBody>
@@ -8621,7 +8621,7 @@
                 </a:solidFill>
                 <a:latin typeface="Microsoft YaHei"/>
               </a:rPr>
-              <a:t>离焦图经 VAE 压缩后，细结构还剩多少</a:t>
+              <a:t>VAE 编码可能削弱细结构修正</a:t>
             </a:r>
           </a:p>
         </p:txBody>
@@ -8930,7 +8930,7 @@
                 </a:solidFill>
                 <a:latin typeface="Microsoft YaHei"/>
               </a:rPr>
-              <a:t>鸭头全 25 帧局部修正</a:t>
+              <a:t>鸭头修正扩展到全部 25 帧</a:t>
             </a:r>
           </a:p>
         </p:txBody>

</xml_diff>